<commit_message>
Add weekly video highlights and Week 1 learning card
</commit_message>
<xml_diff>
--- a/materials/Week1_教學簡報.pptx
+++ b/materials/Week1_教學簡報.pptx
@@ -2,29 +2,30 @@
 <file path=ppt/presentation.xml><?xml version="1.0" encoding="utf-8"?>
 <p:presentation xmlns:p="http://schemas.openxmlformats.org/presentationml/2006/main">
   <p:sldMasterIdLst>
-    <p:sldMasterId xmlns:r="http://schemas.openxmlformats.org/officeDocument/2006/relationships" id="2147483648" r:id="R186fd9b08d234cf8"/>
+    <p:sldMasterId xmlns:r="http://schemas.openxmlformats.org/officeDocument/2006/relationships" id="2147483648" r:id="R5767ec0237654f59"/>
   </p:sldMasterIdLst>
   <p:notesMasterIdLst>
-    <p:notesMasterId xmlns:r="http://schemas.openxmlformats.org/officeDocument/2006/relationships" r:id="R92eaa96e12d04d07"/>
+    <p:notesMasterId xmlns:r="http://schemas.openxmlformats.org/officeDocument/2006/relationships" r:id="R983e08f26cb74e9e"/>
   </p:notesMasterIdLst>
   <p:sldIdLst>
-    <p:sldId xmlns:r="http://schemas.openxmlformats.org/officeDocument/2006/relationships" id="256" r:id="R0732cab328194c8e"/>
-    <p:sldId xmlns:r="http://schemas.openxmlformats.org/officeDocument/2006/relationships" id="257" r:id="R902d2f8919b640f9"/>
-    <p:sldId xmlns:r="http://schemas.openxmlformats.org/officeDocument/2006/relationships" id="258" r:id="Ra2f3005e8b1c4e89"/>
-    <p:sldId xmlns:r="http://schemas.openxmlformats.org/officeDocument/2006/relationships" id="259" r:id="Rf6069bf8fcda4e02"/>
-    <p:sldId xmlns:r="http://schemas.openxmlformats.org/officeDocument/2006/relationships" id="260" r:id="Ra7002ed902374514"/>
-    <p:sldId xmlns:r="http://schemas.openxmlformats.org/officeDocument/2006/relationships" id="261" r:id="R2fa16f1907364068"/>
-    <p:sldId xmlns:r="http://schemas.openxmlformats.org/officeDocument/2006/relationships" id="262" r:id="R1037d58a9321440e"/>
-    <p:sldId xmlns:r="http://schemas.openxmlformats.org/officeDocument/2006/relationships" id="263" r:id="R8ddd4ee241674106"/>
-    <p:sldId xmlns:r="http://schemas.openxmlformats.org/officeDocument/2006/relationships" id="264" r:id="Rffe844c1f81b4f8d"/>
-    <p:sldId xmlns:r="http://schemas.openxmlformats.org/officeDocument/2006/relationships" id="265" r:id="R9e8aa1549b864ee0"/>
-    <p:sldId xmlns:r="http://schemas.openxmlformats.org/officeDocument/2006/relationships" id="266" r:id="R10ffbcef0eb84631"/>
-    <p:sldId xmlns:r="http://schemas.openxmlformats.org/officeDocument/2006/relationships" id="267" r:id="Re5b0776b79644d2e"/>
-    <p:sldId xmlns:r="http://schemas.openxmlformats.org/officeDocument/2006/relationships" id="268" r:id="Rd58cafeda7b940da"/>
-    <p:sldId xmlns:r="http://schemas.openxmlformats.org/officeDocument/2006/relationships" id="269" r:id="R7cd4aeb46c6c4e3e"/>
-    <p:sldId xmlns:r="http://schemas.openxmlformats.org/officeDocument/2006/relationships" id="270" r:id="Rc8c2e0880f714df7"/>
-    <p:sldId xmlns:r="http://schemas.openxmlformats.org/officeDocument/2006/relationships" id="271" r:id="R57b51972e3ae46bb"/>
-    <p:sldId xmlns:r="http://schemas.openxmlformats.org/officeDocument/2006/relationships" id="272" r:id="R6e17ac5f2228411f"/>
+    <p:sldId xmlns:r="http://schemas.openxmlformats.org/officeDocument/2006/relationships" id="256" r:id="Rd77ab7ce2e2a4ad9"/>
+    <p:sldId xmlns:r="http://schemas.openxmlformats.org/officeDocument/2006/relationships" id="257" r:id="Rc4edf0f7661d4eae"/>
+    <p:sldId xmlns:r="http://schemas.openxmlformats.org/officeDocument/2006/relationships" id="258" r:id="R0b8e33c9b2d34e00"/>
+    <p:sldId xmlns:r="http://schemas.openxmlformats.org/officeDocument/2006/relationships" id="259" r:id="Raaab909eabd24561"/>
+    <p:sldId xmlns:r="http://schemas.openxmlformats.org/officeDocument/2006/relationships" id="260" r:id="R8319a30dbffd4038"/>
+    <p:sldId xmlns:r="http://schemas.openxmlformats.org/officeDocument/2006/relationships" id="261" r:id="R414074f02f134462"/>
+    <p:sldId xmlns:r="http://schemas.openxmlformats.org/officeDocument/2006/relationships" id="262" r:id="R39eb0f2e7d0b41d0"/>
+    <p:sldId xmlns:r="http://schemas.openxmlformats.org/officeDocument/2006/relationships" id="263" r:id="R9a75e19b71b44ad7"/>
+    <p:sldId xmlns:r="http://schemas.openxmlformats.org/officeDocument/2006/relationships" id="264" r:id="R6daf0d6456dc430e"/>
+    <p:sldId xmlns:r="http://schemas.openxmlformats.org/officeDocument/2006/relationships" id="265" r:id="R99a21fe7a6354448"/>
+    <p:sldId xmlns:r="http://schemas.openxmlformats.org/officeDocument/2006/relationships" id="266" r:id="R90331592469f4d0d"/>
+    <p:sldId xmlns:r="http://schemas.openxmlformats.org/officeDocument/2006/relationships" id="267" r:id="R48006313672744f1"/>
+    <p:sldId xmlns:r="http://schemas.openxmlformats.org/officeDocument/2006/relationships" id="268" r:id="R794ff15231864cdf"/>
+    <p:sldId xmlns:r="http://schemas.openxmlformats.org/officeDocument/2006/relationships" id="269" r:id="R52e44bb8eff94c89"/>
+    <p:sldId xmlns:r="http://schemas.openxmlformats.org/officeDocument/2006/relationships" id="270" r:id="R31eac73fb2814c05"/>
+    <p:sldId xmlns:r="http://schemas.openxmlformats.org/officeDocument/2006/relationships" id="271" r:id="Re2155ab2049d41cf"/>
+    <p:sldId xmlns:r="http://schemas.openxmlformats.org/officeDocument/2006/relationships" id="272" r:id="R5285ff8669454da9"/>
+    <p:sldId xmlns:r="http://schemas.openxmlformats.org/officeDocument/2006/relationships" id="273" r:id="R0937659659c645d2"/>
   </p:sldIdLst>
   <p:sldSz cx="12192000" cy="6858000"/>
   <p:notesSz cx="6858000" cy="9144000"/>
@@ -1048,6 +1049,76 @@
 </p:notes>
 </file>
 
+<file path=ppt/notesSlides/notesSlide18.xml><?xml version="1.0" encoding="utf-8"?>
+<p:notes xmlns:p="http://schemas.openxmlformats.org/presentationml/2006/main">
+  <p:cSld>
+    <p:spTree>
+      <p:nvGrpSpPr>
+        <p:cNvPr id="1" name=""/>
+        <p:cNvGrpSpPr/>
+        <p:nvPr/>
+      </p:nvGrpSpPr>
+      <p:grpSpPr>
+        <a:xfrm xmlns:a="http://schemas.openxmlformats.org/drawingml/2006/main"/>
+      </p:grpSpPr>
+      <p:sp>
+        <p:nvSpPr>
+          <p:cNvPr id="2" name="Slide Image Placeholder 1"/>
+          <p:cNvSpPr>
+            <a:spLocks xmlns:a="http://schemas.openxmlformats.org/drawingml/2006/main" noGrp="1"/>
+          </p:cNvSpPr>
+          <p:nvPr>
+            <p:ph type="sldImg" idx="0"/>
+          </p:nvPr>
+        </p:nvSpPr>
+        <p:spPr/>
+      </p:sp>
+      <p:sp>
+        <p:nvSpPr>
+          <p:cNvPr id="3" name="Notes Placeholder 2"/>
+          <p:cNvSpPr>
+            <a:spLocks xmlns:a="http://schemas.openxmlformats.org/drawingml/2006/main" noGrp="1"/>
+          </p:cNvSpPr>
+          <p:nvPr>
+            <p:ph type="body" idx="1"/>
+          </p:nvPr>
+        </p:nvSpPr>
+        <p:spPr/>
+        <p:txBody>
+          <a:bodyPr xmlns:a="http://schemas.openxmlformats.org/drawingml/2006/main"/>
+          <a:lstStyle xmlns:a="http://schemas.openxmlformats.org/drawingml/2006/main"/>
+          <a:p xmlns:a="http://schemas.openxmlformats.org/drawingml/2006/main">
+            <a:r>
+              <a:t/>
+            </a:r>
+          </a:p>
+        </p:txBody>
+      </p:sp>
+      <p:sp>
+        <p:nvSpPr>
+          <p:cNvPr id="4" name="Slide Number Placeholder 3"/>
+          <p:cNvSpPr>
+            <a:spLocks xmlns:a="http://schemas.openxmlformats.org/drawingml/2006/main" noGrp="1"/>
+          </p:cNvSpPr>
+          <p:nvPr>
+            <p:ph type="sldNum" idx="5"/>
+          </p:nvPr>
+        </p:nvSpPr>
+        <p:spPr/>
+        <p:txBody>
+          <a:bodyPr xmlns:a="http://schemas.openxmlformats.org/drawingml/2006/main"/>
+          <a:lstStyle xmlns:a="http://schemas.openxmlformats.org/drawingml/2006/main"/>
+          <a:p xmlns:a="http://schemas.openxmlformats.org/drawingml/2006/main"/>
+        </p:txBody>
+      </p:sp>
+    </p:spTree>
+  </p:cSld>
+  <p:clrMapOvr>
+    <a:masterClrMapping xmlns:a="http://schemas.openxmlformats.org/drawingml/2006/main"/>
+  </p:clrMapOvr>
+</p:notes>
+</file>
+
 <file path=ppt/notesSlides/notesSlide2.xml><?xml version="1.0" encoding="utf-8"?>
 <p:notes xmlns:p="http://schemas.openxmlformats.org/presentationml/2006/main">
   <p:cSld>
@@ -1646,7 +1717,7 @@
   </p:cSld>
   <p:clrMap bg1="lt1" tx1="dk1" bg2="lt2" tx2="dk2" accent1="accent1" accent2="accent2" accent3="accent3" accent4="accent4" accent5="accent5" accent6="accent6" hlink="hlink" folHlink="folHlink"/>
   <p:sldLayoutIdLst>
-    <p:sldLayoutId xmlns:r="http://schemas.openxmlformats.org/officeDocument/2006/relationships" id="2147483649" r:id="R468733c1ddcb4b57"/>
+    <p:sldLayoutId xmlns:r="http://schemas.openxmlformats.org/officeDocument/2006/relationships" id="2147483649" r:id="Re3981b947de54886"/>
   </p:sldLayoutIdLst>
   <p:txStyles>
     <p:titleStyle>
@@ -2201,7 +2272,7 @@
           <p:nvPr/>
         </p:nvPicPr>
         <p:blipFill>
-          <a:blip xmlns:r="http://schemas.openxmlformats.org/officeDocument/2006/relationships" xmlns:a="http://schemas.openxmlformats.org/drawingml/2006/main" r:embed="Rc5ce5e2d566f4c78"/>
+          <a:blip xmlns:r="http://schemas.openxmlformats.org/officeDocument/2006/relationships" xmlns:a="http://schemas.openxmlformats.org/drawingml/2006/main" r:embed="R5726a8d217c24028"/>
           <a:srcRect xmlns:a="http://schemas.openxmlformats.org/drawingml/2006/main" l="24930" t="0" r="24930" b="0"/>
           <a:stretch xmlns:a="http://schemas.openxmlformats.org/drawingml/2006/main">
             <a:fillRect l="0" t="0" r="0" b="0"/>
@@ -2224,7 +2295,7 @@
           <p:cNvPr id="2" name="">
             <a:extLst xmlns:a="http://schemas.openxmlformats.org/drawingml/2006/main">
               <a:ext uri="{FF2B5EF4-FFF2-40B4-BE49-F238E27FC236}">
-                <a16:creationId xmlns:a16="http://schemas.microsoft.com/office/drawing/2014/main" id="{65ADFF38-EA17-4BD4-AE22-01ADDFEF0CD3}"/>
+                <a16:creationId xmlns:a16="http://schemas.microsoft.com/office/drawing/2014/main" id="{B883B04B-2964-4AFD-B626-FB0B8D4B5B6F}"/>
               </a:ext>
             </a:extLst>
           </p:cNvPr>
@@ -2281,7 +2352,7 @@
           <p:cNvPr id="3" name="">
             <a:extLst xmlns:a="http://schemas.openxmlformats.org/drawingml/2006/main">
               <a:ext uri="{FF2B5EF4-FFF2-40B4-BE49-F238E27FC236}">
-                <a16:creationId xmlns:a16="http://schemas.microsoft.com/office/drawing/2014/main" id="{9A21596B-678F-48C8-B472-1603F381AA41}"/>
+                <a16:creationId xmlns:a16="http://schemas.microsoft.com/office/drawing/2014/main" id="{9A25FB6A-0A57-4D01-A930-6DB90C8B1D0C}"/>
               </a:ext>
             </a:extLst>
           </p:cNvPr>
@@ -2361,7 +2432,7 @@
           <p:cNvPr id="4" name="">
             <a:extLst xmlns:a="http://schemas.openxmlformats.org/drawingml/2006/main">
               <a:ext uri="{FF2B5EF4-FFF2-40B4-BE49-F238E27FC236}">
-                <a16:creationId xmlns:a16="http://schemas.microsoft.com/office/drawing/2014/main" id="{44E66D85-ABD3-4D26-A942-CDAD0B1AF66E}"/>
+                <a16:creationId xmlns:a16="http://schemas.microsoft.com/office/drawing/2014/main" id="{FB1BAD61-3DF2-4CD2-93F9-F44BA76F1AAA}"/>
               </a:ext>
             </a:extLst>
           </p:cNvPr>
@@ -2416,7 +2487,7 @@
     </p:spTree>
     <p:extLst>
       <p:ext uri="{BB962C8B-B14F-4D97-AF65-F5344CB8AC3E}">
-        <p14:creationId xmlns:p14="http://schemas.microsoft.com/office/powerpoint/2010/main" val="1246835366"/>
+        <p14:creationId xmlns:p14="http://schemas.microsoft.com/office/powerpoint/2010/main" val="32094776"/>
       </p:ext>
     </p:extLst>
   </p:cSld>
@@ -2447,7 +2518,7 @@
           <p:cNvPr id="4" name="">
             <a:extLst xmlns:a="http://schemas.openxmlformats.org/drawingml/2006/main">
               <a:ext uri="{FF2B5EF4-FFF2-40B4-BE49-F238E27FC236}">
-                <a16:creationId xmlns:a16="http://schemas.microsoft.com/office/drawing/2014/main" id="{57B104FC-51C2-4FF6-8D29-C4C8CC14C578}"/>
+                <a16:creationId xmlns:a16="http://schemas.microsoft.com/office/drawing/2014/main" id="{D0B76725-3ABF-458B-A2E6-67A44CF095C8}"/>
               </a:ext>
             </a:extLst>
           </p:cNvPr>
@@ -2494,7 +2565,7 @@
                 <a:ea typeface="Helvetica Neue"/>
                 <a:cs typeface="Helvetica Neue"/>
               </a:rPr>
-              <a:t>影片重點三：先學習，再下結論</a:t>
+              <a:t>影片重點二：動機需要經得起困難</a:t>
             </a:r>
           </a:p>
         </p:txBody>
@@ -2504,7 +2575,7 @@
           <p:cNvPr id="2" name="">
             <a:extLst xmlns:a="http://schemas.openxmlformats.org/drawingml/2006/main">
               <a:ext uri="{FF2B5EF4-FFF2-40B4-BE49-F238E27FC236}">
-                <a16:creationId xmlns:a16="http://schemas.microsoft.com/office/drawing/2014/main" id="{007CC123-2226-4083-9C15-16363A786224}"/>
+                <a16:creationId xmlns:a16="http://schemas.microsoft.com/office/drawing/2014/main" id="{6225833A-D1E1-4AF8-8914-6A9AF3FE8702}"/>
               </a:ext>
             </a:extLst>
           </p:cNvPr>
@@ -2551,7 +2622,7 @@
                 <a:ea typeface="Helvetica Neue"/>
                 <a:cs typeface="Helvetica Neue"/>
               </a:rPr>
-              <a:t>你現在知道的，可能只是局部觀察。</a:t>
+              <a:t>創業會遇到不確定、拒絕與反覆修改。</a:t>
             </a:r>
           </a:p>
           <a:p xmlns:a="http://schemas.openxmlformats.org/drawingml/2006/main">
@@ -2574,7 +2645,7 @@
                 <a:ea typeface="Helvetica Neue"/>
                 <a:cs typeface="Helvetica Neue"/>
               </a:rPr>
-              <a:t>把「我看到的」寫成事實。</a:t>
+              <a:t>你的動機應該來自對問題與使用者的關心。</a:t>
             </a:r>
           </a:p>
           <a:p xmlns:a="http://schemas.openxmlformats.org/drawingml/2006/main">
@@ -2597,7 +2668,7 @@
                 <a:ea typeface="Helvetica Neue"/>
                 <a:cs typeface="Helvetica Neue"/>
               </a:rPr>
-              <a:t>把「我認為使用者會需要的」寫成待驗證假設。</a:t>
+              <a:t>第一週不用承諾要創業，只要誠實探索。</a:t>
             </a:r>
           </a:p>
         </p:txBody>
@@ -2607,7 +2678,7 @@
           <p:cNvPr id="3" name="">
             <a:extLst xmlns:a="http://schemas.openxmlformats.org/drawingml/2006/main">
               <a:ext uri="{FF2B5EF4-FFF2-40B4-BE49-F238E27FC236}">
-                <a16:creationId xmlns:a16="http://schemas.microsoft.com/office/drawing/2014/main" id="{AD1D72B2-E8E4-407E-9187-BA6F973AD370}"/>
+                <a16:creationId xmlns:a16="http://schemas.microsoft.com/office/drawing/2014/main" id="{43FA790A-A3F3-46D3-9EDD-E3CB03A2062A}"/>
               </a:ext>
             </a:extLst>
           </p:cNvPr>
@@ -2662,7 +2733,7 @@
     </p:spTree>
     <p:extLst>
       <p:ext uri="{BB962C8B-B14F-4D97-AF65-F5344CB8AC3E}">
-        <p14:creationId xmlns:p14="http://schemas.microsoft.com/office/powerpoint/2010/main" val="1471460955"/>
+        <p14:creationId xmlns:p14="http://schemas.microsoft.com/office/powerpoint/2010/main" val="54546159"/>
       </p:ext>
     </p:extLst>
   </p:cSld>
@@ -2693,7 +2764,7 @@
           <p:cNvPr id="4" name="">
             <a:extLst xmlns:a="http://schemas.openxmlformats.org/drawingml/2006/main">
               <a:ext uri="{FF2B5EF4-FFF2-40B4-BE49-F238E27FC236}">
-                <a16:creationId xmlns:a16="http://schemas.microsoft.com/office/drawing/2014/main" id="{FE560E7E-EFC5-43E0-B70B-5F5E590FA5DA}"/>
+                <a16:creationId xmlns:a16="http://schemas.microsoft.com/office/drawing/2014/main" id="{F30A901D-8298-4F5D-A91A-CE2018D91EFC}"/>
               </a:ext>
             </a:extLst>
           </p:cNvPr>
@@ -2740,7 +2811,7 @@
                 <a:ea typeface="Helvetica Neue"/>
                 <a:cs typeface="Helvetica Neue"/>
               </a:rPr>
-              <a:t>四個討論問題與範例</a:t>
+              <a:t>影片重點三：先學習，再下結論</a:t>
             </a:r>
           </a:p>
         </p:txBody>
@@ -2750,7 +2821,7 @@
           <p:cNvPr id="2" name="">
             <a:extLst xmlns:a="http://schemas.openxmlformats.org/drawingml/2006/main">
               <a:ext uri="{FF2B5EF4-FFF2-40B4-BE49-F238E27FC236}">
-                <a16:creationId xmlns:a16="http://schemas.microsoft.com/office/drawing/2014/main" id="{EC678EEA-92B7-445F-A368-2E5DBDB1E0E4}"/>
+                <a16:creationId xmlns:a16="http://schemas.microsoft.com/office/drawing/2014/main" id="{584C75BD-DD29-408E-AB90-DF7181CE07E3}"/>
               </a:ext>
             </a:extLst>
           </p:cNvPr>
@@ -2797,7 +2868,7 @@
                 <a:ea typeface="Helvetica Neue"/>
                 <a:cs typeface="Helvetica Neue"/>
               </a:rPr>
-              <a:t>1. 為什麼關心？我常因午餐排隊吃得很趕。</a:t>
+              <a:t>你現在知道的，可能只是局部觀察。</a:t>
             </a:r>
           </a:p>
           <a:p xmlns:a="http://schemas.openxmlformats.org/drawingml/2006/main">
@@ -2820,7 +2891,7 @@
                 <a:ea typeface="Helvetica Neue"/>
                 <a:cs typeface="Helvetica Neue"/>
               </a:rPr>
-              <a:t>2. 原句是什麼？「我又要遲到了，午餐排隊根本來不及。」</a:t>
+              <a:t>把「我看到的」寫成事實。</a:t>
             </a:r>
           </a:p>
           <a:p xmlns:a="http://schemas.openxmlformats.org/drawingml/2006/main">
@@ -2843,30 +2914,7 @@
                 <a:ea typeface="Helvetica Neue"/>
                 <a:cs typeface="Helvetica Neue"/>
               </a:rPr>
-              <a:t>3. 事實是什麼？星期三 12:10 至 12:30 有約 20 人排隊。</a:t>
-            </a:r>
-          </a:p>
-          <a:p xmlns:a="http://schemas.openxmlformats.org/drawingml/2006/main">
-            <a:pPr>
-              <a:defRPr sz="1875">
-                <a:solidFill>
-                  <a:srgbClr val="263238"/>
-                </a:solidFill>
-                <a:latin typeface="Helvetica Neue"/>
-                <a:ea typeface="Helvetica Neue"/>
-                <a:cs typeface="Helvetica Neue"/>
-              </a:defRPr>
-            </a:pPr>
-            <a:r>
-              <a:rPr sz="1875">
-                <a:solidFill>
-                  <a:srgbClr val="263238"/>
-                </a:solidFill>
-                <a:latin typeface="Helvetica Neue"/>
-                <a:ea typeface="Helvetica Neue"/>
-                <a:cs typeface="Helvetica Neue"/>
-              </a:rPr>
-              <a:t>4. 還不知道什麼？學生是否願意提前選餐換取較短等待。</a:t>
+              <a:t>把「我認為使用者會需要的」寫成待驗證假設。</a:t>
             </a:r>
           </a:p>
         </p:txBody>
@@ -2876,7 +2924,7 @@
           <p:cNvPr id="3" name="">
             <a:extLst xmlns:a="http://schemas.openxmlformats.org/drawingml/2006/main">
               <a:ext uri="{FF2B5EF4-FFF2-40B4-BE49-F238E27FC236}">
-                <a16:creationId xmlns:a16="http://schemas.microsoft.com/office/drawing/2014/main" id="{8021254B-8011-4398-A30D-6EB5CB205F98}"/>
+                <a16:creationId xmlns:a16="http://schemas.microsoft.com/office/drawing/2014/main" id="{6FAD494D-79D2-499D-B0CF-EC7DF60FF408}"/>
               </a:ext>
             </a:extLst>
           </p:cNvPr>
@@ -2931,7 +2979,7 @@
     </p:spTree>
     <p:extLst>
       <p:ext uri="{BB962C8B-B14F-4D97-AF65-F5344CB8AC3E}">
-        <p14:creationId xmlns:p14="http://schemas.microsoft.com/office/powerpoint/2010/main" val="1438904963"/>
+        <p14:creationId xmlns:p14="http://schemas.microsoft.com/office/powerpoint/2010/main" val="1348729746"/>
       </p:ext>
     </p:extLst>
   </p:cSld>
@@ -2962,7 +3010,7 @@
           <p:cNvPr id="4" name="">
             <a:extLst xmlns:a="http://schemas.openxmlformats.org/drawingml/2006/main">
               <a:ext uri="{FF2B5EF4-FFF2-40B4-BE49-F238E27FC236}">
-                <a16:creationId xmlns:a16="http://schemas.microsoft.com/office/drawing/2014/main" id="{9FE49A7F-C09A-4551-9C7D-D0A98F752330}"/>
+                <a16:creationId xmlns:a16="http://schemas.microsoft.com/office/drawing/2014/main" id="{AE535024-FFE8-4700-B066-EBC6815B78D5}"/>
               </a:ext>
             </a:extLst>
           </p:cNvPr>
@@ -3009,7 +3057,7 @@
                 <a:ea typeface="Helvetica Neue"/>
                 <a:cs typeface="Helvetica Neue"/>
               </a:rPr>
-              <a:t>Week 1 的成功標準</a:t>
+              <a:t>四個討論問題與範例</a:t>
             </a:r>
           </a:p>
         </p:txBody>
@@ -3019,7 +3067,7 @@
           <p:cNvPr id="2" name="">
             <a:extLst xmlns:a="http://schemas.openxmlformats.org/drawingml/2006/main">
               <a:ext uri="{FF2B5EF4-FFF2-40B4-BE49-F238E27FC236}">
-                <a16:creationId xmlns:a16="http://schemas.microsoft.com/office/drawing/2014/main" id="{09104EB9-9561-4666-A99B-BEB44BBBA71C}"/>
+                <a16:creationId xmlns:a16="http://schemas.microsoft.com/office/drawing/2014/main" id="{811C70D0-2027-4B26-B604-C61A2C70B581}"/>
               </a:ext>
             </a:extLst>
           </p:cNvPr>
@@ -3066,7 +3114,7 @@
                 <a:ea typeface="Helvetica Neue"/>
                 <a:cs typeface="Helvetica Neue"/>
               </a:rPr>
-              <a:t>完成一則真實觀察。</a:t>
+              <a:t>1. 為什麼關心？我常因午餐排隊吃得很趕。</a:t>
             </a:r>
           </a:p>
           <a:p xmlns:a="http://schemas.openxmlformats.org/drawingml/2006/main">
@@ -3089,7 +3137,7 @@
                 <a:ea typeface="Helvetica Neue"/>
                 <a:cs typeface="Helvetica Neue"/>
               </a:rPr>
-              <a:t>分開「我看到的事實」與「我仍在猜的假設」。</a:t>
+              <a:t>2. 原句是什麼？「我又要遲到了，午餐排隊根本來不及。」</a:t>
             </a:r>
           </a:p>
           <a:p xmlns:a="http://schemas.openxmlformats.org/drawingml/2006/main">
@@ -3112,12 +3160,7 @@
                 <a:ea typeface="Helvetica Neue"/>
                 <a:cs typeface="Helvetica Neue"/>
               </a:rPr>
-              <a:t>留下下週最想問使用者的一題。</a:t>
-            </a:r>
-          </a:p>
-          <a:p xmlns:a="http://schemas.openxmlformats.org/drawingml/2006/main">
-            <a:r>
-              <a:t/>
+              <a:t>3. 事實是什麼？星期三 12:10 至 12:30 有約 20 人排隊。</a:t>
             </a:r>
           </a:p>
           <a:p xmlns:a="http://schemas.openxmlformats.org/drawingml/2006/main">
@@ -3140,7 +3183,7 @@
                 <a:ea typeface="Helvetica Neue"/>
                 <a:cs typeface="Helvetica Neue"/>
               </a:rPr>
-              <a:t>不需要提出好解法。</a:t>
+              <a:t>4. 還不知道什麼？學生是否願意提前選餐換取較短等待。</a:t>
             </a:r>
           </a:p>
         </p:txBody>
@@ -3150,7 +3193,7 @@
           <p:cNvPr id="3" name="">
             <a:extLst xmlns:a="http://schemas.openxmlformats.org/drawingml/2006/main">
               <a:ext uri="{FF2B5EF4-FFF2-40B4-BE49-F238E27FC236}">
-                <a16:creationId xmlns:a16="http://schemas.microsoft.com/office/drawing/2014/main" id="{BBD40DDB-34E6-46E0-A17B-8CD850B89C87}"/>
+                <a16:creationId xmlns:a16="http://schemas.microsoft.com/office/drawing/2014/main" id="{CED6C044-31D2-44C3-B1E7-9F1CDAA44FBC}"/>
               </a:ext>
             </a:extLst>
           </p:cNvPr>
@@ -3205,7 +3248,7 @@
     </p:spTree>
     <p:extLst>
       <p:ext uri="{BB962C8B-B14F-4D97-AF65-F5344CB8AC3E}">
-        <p14:creationId xmlns:p14="http://schemas.microsoft.com/office/powerpoint/2010/main" val="691138134"/>
+        <p14:creationId xmlns:p14="http://schemas.microsoft.com/office/powerpoint/2010/main" val="593541600"/>
       </p:ext>
     </p:extLst>
   </p:cSld>
@@ -3236,7 +3279,7 @@
           <p:cNvPr id="4" name="">
             <a:extLst xmlns:a="http://schemas.openxmlformats.org/drawingml/2006/main">
               <a:ext uri="{FF2B5EF4-FFF2-40B4-BE49-F238E27FC236}">
-                <a16:creationId xmlns:a16="http://schemas.microsoft.com/office/drawing/2014/main" id="{CFF2CA9D-48A4-4AC1-8CBA-B98D40E883D8}"/>
+                <a16:creationId xmlns:a16="http://schemas.microsoft.com/office/drawing/2014/main" id="{57D331E4-467E-465B-9EBA-56486E0F9597}"/>
               </a:ext>
             </a:extLst>
           </p:cNvPr>
@@ -3283,7 +3326,7 @@
                 <a:ea typeface="Helvetica Neue"/>
                 <a:cs typeface="Helvetica Neue"/>
               </a:rPr>
-              <a:t>影片討論</a:t>
+              <a:t>Week 1 的成功標準</a:t>
             </a:r>
           </a:p>
         </p:txBody>
@@ -3293,7 +3336,7 @@
           <p:cNvPr id="2" name="">
             <a:extLst xmlns:a="http://schemas.openxmlformats.org/drawingml/2006/main">
               <a:ext uri="{FF2B5EF4-FFF2-40B4-BE49-F238E27FC236}">
-                <a16:creationId xmlns:a16="http://schemas.microsoft.com/office/drawing/2014/main" id="{4E89E3F6-1206-47C7-ACD3-22866896D92C}"/>
+                <a16:creationId xmlns:a16="http://schemas.microsoft.com/office/drawing/2014/main" id="{C5D63CD4-2840-4431-A402-57C22A194733}"/>
               </a:ext>
             </a:extLst>
           </p:cNvPr>
@@ -3340,7 +3383,7 @@
                 <a:ea typeface="Helvetica Neue"/>
                 <a:cs typeface="Helvetica Neue"/>
               </a:rPr>
-              <a:t>我為什麼關心這個問題？</a:t>
+              <a:t>完成一則真實觀察。</a:t>
             </a:r>
           </a:p>
           <a:p xmlns:a="http://schemas.openxmlformats.org/drawingml/2006/main">
@@ -3363,7 +3406,7 @@
                 <a:ea typeface="Helvetica Neue"/>
                 <a:cs typeface="Helvetica Neue"/>
               </a:rPr>
-              <a:t>我目前知道哪些事實？</a:t>
+              <a:t>分開「我看到的事實」與「我仍在猜的假設」。</a:t>
             </a:r>
           </a:p>
           <a:p xmlns:a="http://schemas.openxmlformats.org/drawingml/2006/main">
@@ -3386,7 +3429,12 @@
                 <a:ea typeface="Helvetica Neue"/>
                 <a:cs typeface="Helvetica Neue"/>
               </a:rPr>
-              <a:t>我還不知道什麼？</a:t>
+              <a:t>留下下週最想問使用者的一題。</a:t>
+            </a:r>
+          </a:p>
+          <a:p xmlns:a="http://schemas.openxmlformats.org/drawingml/2006/main">
+            <a:r>
+              <a:t/>
             </a:r>
           </a:p>
           <a:p xmlns:a="http://schemas.openxmlformats.org/drawingml/2006/main">
@@ -3409,7 +3457,7 @@
                 <a:ea typeface="Helvetica Neue"/>
                 <a:cs typeface="Helvetica Neue"/>
               </a:rPr>
-              <a:t>如果下週只做一件事，我要找誰、問什麼？</a:t>
+              <a:t>不需要提出好解法。</a:t>
             </a:r>
           </a:p>
         </p:txBody>
@@ -3419,7 +3467,7 @@
           <p:cNvPr id="3" name="">
             <a:extLst xmlns:a="http://schemas.openxmlformats.org/drawingml/2006/main">
               <a:ext uri="{FF2B5EF4-FFF2-40B4-BE49-F238E27FC236}">
-                <a16:creationId xmlns:a16="http://schemas.microsoft.com/office/drawing/2014/main" id="{5BE26281-9913-4294-9A3B-DAFB837EB269}"/>
+                <a16:creationId xmlns:a16="http://schemas.microsoft.com/office/drawing/2014/main" id="{AB2DA8D8-0E42-4B7A-A9AF-F38390D38BAA}"/>
               </a:ext>
             </a:extLst>
           </p:cNvPr>
@@ -3474,7 +3522,7 @@
     </p:spTree>
     <p:extLst>
       <p:ext uri="{BB962C8B-B14F-4D97-AF65-F5344CB8AC3E}">
-        <p14:creationId xmlns:p14="http://schemas.microsoft.com/office/powerpoint/2010/main" val="376536020"/>
+        <p14:creationId xmlns:p14="http://schemas.microsoft.com/office/powerpoint/2010/main" val="2008224776"/>
       </p:ext>
     </p:extLst>
   </p:cSld>
@@ -3505,7 +3553,7 @@
           <p:cNvPr id="4" name="">
             <a:extLst xmlns:a="http://schemas.openxmlformats.org/drawingml/2006/main">
               <a:ext uri="{FF2B5EF4-FFF2-40B4-BE49-F238E27FC236}">
-                <a16:creationId xmlns:a16="http://schemas.microsoft.com/office/drawing/2014/main" id="{6AB035FF-F2D1-4E33-81C8-92A758BDCCBB}"/>
+                <a16:creationId xmlns:a16="http://schemas.microsoft.com/office/drawing/2014/main" id="{6A8C9560-C095-482D-9FD0-8D3B30D27A88}"/>
               </a:ext>
             </a:extLst>
           </p:cNvPr>
@@ -3552,7 +3600,7 @@
                 <a:ea typeface="Helvetica Neue"/>
                 <a:cs typeface="Helvetica Neue"/>
               </a:rPr>
-              <a:t>事實與假設練習</a:t>
+              <a:t>影片討論</a:t>
             </a:r>
           </a:p>
         </p:txBody>
@@ -3562,7 +3610,7 @@
           <p:cNvPr id="2" name="">
             <a:extLst xmlns:a="http://schemas.openxmlformats.org/drawingml/2006/main">
               <a:ext uri="{FF2B5EF4-FFF2-40B4-BE49-F238E27FC236}">
-                <a16:creationId xmlns:a16="http://schemas.microsoft.com/office/drawing/2014/main" id="{34CBA8BE-39DE-4AF5-808A-176FB9E02DB8}"/>
+                <a16:creationId xmlns:a16="http://schemas.microsoft.com/office/drawing/2014/main" id="{1AA3DD8C-0A64-42A9-A4FF-D2A02031F6F7}"/>
               </a:ext>
             </a:extLst>
           </p:cNvPr>
@@ -3609,12 +3657,7 @@
                 <a:ea typeface="Helvetica Neue"/>
                 <a:cs typeface="Helvetica Neue"/>
               </a:rPr>
-              <a:t>事實：午餐尖峰時，我看到校園餐廳排隊約 20 分鐘。</a:t>
-            </a:r>
-          </a:p>
-          <a:p xmlns:a="http://schemas.openxmlformats.org/drawingml/2006/main">
-            <a:r>
-              <a:t/>
+              <a:t>我為什麼關心這個問題？</a:t>
             </a:r>
           </a:p>
           <a:p xmlns:a="http://schemas.openxmlformats.org/drawingml/2006/main">
@@ -3637,12 +3680,7 @@
                 <a:ea typeface="Helvetica Neue"/>
                 <a:cs typeface="Helvetica Neue"/>
               </a:rPr>
-              <a:t>假設：學生會願意使用預約取餐工具。</a:t>
-            </a:r>
-          </a:p>
-          <a:p xmlns:a="http://schemas.openxmlformats.org/drawingml/2006/main">
-            <a:r>
-              <a:t/>
+              <a:t>我目前知道哪些事實？</a:t>
             </a:r>
           </a:p>
           <a:p xmlns:a="http://schemas.openxmlformats.org/drawingml/2006/main">
@@ -3665,7 +3703,30 @@
                 <a:ea typeface="Helvetica Neue"/>
                 <a:cs typeface="Helvetica Neue"/>
               </a:rPr>
-              <a:t>下一步：訪談正在排隊的學生，了解他們真正的困擾。</a:t>
+              <a:t>我還不知道什麼？</a:t>
+            </a:r>
+          </a:p>
+          <a:p xmlns:a="http://schemas.openxmlformats.org/drawingml/2006/main">
+            <a:pPr>
+              <a:defRPr sz="1875">
+                <a:solidFill>
+                  <a:srgbClr val="263238"/>
+                </a:solidFill>
+                <a:latin typeface="Helvetica Neue"/>
+                <a:ea typeface="Helvetica Neue"/>
+                <a:cs typeface="Helvetica Neue"/>
+              </a:defRPr>
+            </a:pPr>
+            <a:r>
+              <a:rPr sz="1875">
+                <a:solidFill>
+                  <a:srgbClr val="263238"/>
+                </a:solidFill>
+                <a:latin typeface="Helvetica Neue"/>
+                <a:ea typeface="Helvetica Neue"/>
+                <a:cs typeface="Helvetica Neue"/>
+              </a:rPr>
+              <a:t>如果下週只做一件事，我要找誰、問什麼？</a:t>
             </a:r>
           </a:p>
         </p:txBody>
@@ -3675,7 +3736,7 @@
           <p:cNvPr id="3" name="">
             <a:extLst xmlns:a="http://schemas.openxmlformats.org/drawingml/2006/main">
               <a:ext uri="{FF2B5EF4-FFF2-40B4-BE49-F238E27FC236}">
-                <a16:creationId xmlns:a16="http://schemas.microsoft.com/office/drawing/2014/main" id="{A0FB84AB-97A5-4187-891E-20392A9A98FB}"/>
+                <a16:creationId xmlns:a16="http://schemas.microsoft.com/office/drawing/2014/main" id="{23BC51C2-0702-41FB-98CB-5788DD23200B}"/>
               </a:ext>
             </a:extLst>
           </p:cNvPr>
@@ -3730,7 +3791,7 @@
     </p:spTree>
     <p:extLst>
       <p:ext uri="{BB962C8B-B14F-4D97-AF65-F5344CB8AC3E}">
-        <p14:creationId xmlns:p14="http://schemas.microsoft.com/office/powerpoint/2010/main" val="824180252"/>
+        <p14:creationId xmlns:p14="http://schemas.microsoft.com/office/powerpoint/2010/main" val="377776260"/>
       </p:ext>
     </p:extLst>
   </p:cSld>
@@ -3761,7 +3822,7 @@
           <p:cNvPr id="4" name="">
             <a:extLst xmlns:a="http://schemas.openxmlformats.org/drawingml/2006/main">
               <a:ext uri="{FF2B5EF4-FFF2-40B4-BE49-F238E27FC236}">
-                <a16:creationId xmlns:a16="http://schemas.microsoft.com/office/drawing/2014/main" id="{84B2335B-FC23-4D83-9CB5-FCEC7ED25493}"/>
+                <a16:creationId xmlns:a16="http://schemas.microsoft.com/office/drawing/2014/main" id="{634F840B-D30B-47E3-A26A-B717B951C2A7}"/>
               </a:ext>
             </a:extLst>
           </p:cNvPr>
@@ -3808,7 +3869,7 @@
                 <a:ea typeface="Helvetica Neue"/>
                 <a:cs typeface="Helvetica Neue"/>
               </a:rPr>
-              <a:t>個人起點卡</a:t>
+              <a:t>事實與假設練習</a:t>
             </a:r>
           </a:p>
         </p:txBody>
@@ -3818,7 +3879,7 @@
           <p:cNvPr id="2" name="">
             <a:extLst xmlns:a="http://schemas.openxmlformats.org/drawingml/2006/main">
               <a:ext uri="{FF2B5EF4-FFF2-40B4-BE49-F238E27FC236}">
-                <a16:creationId xmlns:a16="http://schemas.microsoft.com/office/drawing/2014/main" id="{94897F5A-C8E2-4A27-BD9C-82B623C115D0}"/>
+                <a16:creationId xmlns:a16="http://schemas.microsoft.com/office/drawing/2014/main" id="{AE096173-E18C-4E42-8002-58F7977DB6E3}"/>
               </a:ext>
             </a:extLst>
           </p:cNvPr>
@@ -3865,7 +3926,7 @@
                 <a:ea typeface="Helvetica Neue"/>
                 <a:cs typeface="Helvetica Neue"/>
               </a:rPr>
-              <a:t>填寫生活不便、受到影響的人、已知事實、待驗證假設、期待與擔心。</a:t>
+              <a:t>事實：午餐尖峰時，我看到校園餐廳排隊約 20 分鐘。</a:t>
             </a:r>
           </a:p>
           <a:p xmlns:a="http://schemas.openxmlformats.org/drawingml/2006/main">
@@ -3893,7 +3954,35 @@
                 <a:ea typeface="Helvetica Neue"/>
                 <a:cs typeface="Helvetica Neue"/>
               </a:rPr>
-              <a:t>網站會保存草稿、顯示完成度，並可匯出。</a:t>
+              <a:t>假設：學生會願意使用預約取餐工具。</a:t>
+            </a:r>
+          </a:p>
+          <a:p xmlns:a="http://schemas.openxmlformats.org/drawingml/2006/main">
+            <a:r>
+              <a:t/>
+            </a:r>
+          </a:p>
+          <a:p xmlns:a="http://schemas.openxmlformats.org/drawingml/2006/main">
+            <a:pPr>
+              <a:defRPr sz="1875">
+                <a:solidFill>
+                  <a:srgbClr val="263238"/>
+                </a:solidFill>
+                <a:latin typeface="Helvetica Neue"/>
+                <a:ea typeface="Helvetica Neue"/>
+                <a:cs typeface="Helvetica Neue"/>
+              </a:defRPr>
+            </a:pPr>
+            <a:r>
+              <a:rPr sz="1875">
+                <a:solidFill>
+                  <a:srgbClr val="263238"/>
+                </a:solidFill>
+                <a:latin typeface="Helvetica Neue"/>
+                <a:ea typeface="Helvetica Neue"/>
+                <a:cs typeface="Helvetica Neue"/>
+              </a:rPr>
+              <a:t>下一步：訪談正在排隊的學生，了解他們真正的困擾。</a:t>
             </a:r>
           </a:p>
         </p:txBody>
@@ -3903,7 +3992,7 @@
           <p:cNvPr id="3" name="">
             <a:extLst xmlns:a="http://schemas.openxmlformats.org/drawingml/2006/main">
               <a:ext uri="{FF2B5EF4-FFF2-40B4-BE49-F238E27FC236}">
-                <a16:creationId xmlns:a16="http://schemas.microsoft.com/office/drawing/2014/main" id="{9751DFC4-A34F-4151-9405-7F36D70E4AE2}"/>
+                <a16:creationId xmlns:a16="http://schemas.microsoft.com/office/drawing/2014/main" id="{E3353A17-7579-4195-AB28-956F3B38D345}"/>
               </a:ext>
             </a:extLst>
           </p:cNvPr>
@@ -3958,7 +4047,7 @@
     </p:spTree>
     <p:extLst>
       <p:ext uri="{BB962C8B-B14F-4D97-AF65-F5344CB8AC3E}">
-        <p14:creationId xmlns:p14="http://schemas.microsoft.com/office/powerpoint/2010/main" val="237090898"/>
+        <p14:creationId xmlns:p14="http://schemas.microsoft.com/office/powerpoint/2010/main" val="1827169562"/>
       </p:ext>
     </p:extLst>
   </p:cSld>
@@ -3989,7 +4078,7 @@
           <p:cNvPr id="4" name="">
             <a:extLst xmlns:a="http://schemas.openxmlformats.org/drawingml/2006/main">
               <a:ext uri="{FF2B5EF4-FFF2-40B4-BE49-F238E27FC236}">
-                <a16:creationId xmlns:a16="http://schemas.microsoft.com/office/drawing/2014/main" id="{4536C3BD-7C87-45C6-9A3F-326519C70E8D}"/>
+                <a16:creationId xmlns:a16="http://schemas.microsoft.com/office/drawing/2014/main" id="{0A74ECA8-A5F2-4C87-B759-69068781D26E}"/>
               </a:ext>
             </a:extLst>
           </p:cNvPr>
@@ -4036,7 +4125,7 @@
                 <a:ea typeface="Helvetica Neue"/>
                 <a:cs typeface="Helvetica Neue"/>
               </a:rPr>
-              <a:t>AI 使用原則</a:t>
+              <a:t>個人起點卡</a:t>
             </a:r>
           </a:p>
         </p:txBody>
@@ -4046,7 +4135,7 @@
           <p:cNvPr id="2" name="">
             <a:extLst xmlns:a="http://schemas.openxmlformats.org/drawingml/2006/main">
               <a:ext uri="{FF2B5EF4-FFF2-40B4-BE49-F238E27FC236}">
-                <a16:creationId xmlns:a16="http://schemas.microsoft.com/office/drawing/2014/main" id="{AED392D9-6D3F-4EF3-9311-79AE5D3210B2}"/>
+                <a16:creationId xmlns:a16="http://schemas.microsoft.com/office/drawing/2014/main" id="{7D63E884-C909-44C7-BB09-056E0C2F2B1B}"/>
               </a:ext>
             </a:extLst>
           </p:cNvPr>
@@ -4093,7 +4182,12 @@
                 <a:ea typeface="Helvetica Neue"/>
                 <a:cs typeface="Helvetica Neue"/>
               </a:rPr>
-              <a:t>AI 可以協助整理、翻譯與草擬問題。</a:t>
+              <a:t>填寫生活不便、受到影響的人、已知事實、待驗證假設、期待與擔心。</a:t>
+            </a:r>
+          </a:p>
+          <a:p xmlns:a="http://schemas.openxmlformats.org/drawingml/2006/main">
+            <a:r>
+              <a:t/>
             </a:r>
           </a:p>
           <a:p xmlns:a="http://schemas.openxmlformats.org/drawingml/2006/main">
@@ -4116,7 +4210,7 @@
                 <a:ea typeface="Helvetica Neue"/>
                 <a:cs typeface="Helvetica Neue"/>
               </a:rPr>
-              <a:t>學生要保存原始觀察，查核 AI 的內容，不能捏造訪談或使用者資料。</a:t>
+              <a:t>網站會保存草稿、顯示完成度，並可匯出。</a:t>
             </a:r>
           </a:p>
         </p:txBody>
@@ -4126,7 +4220,7 @@
           <p:cNvPr id="3" name="">
             <a:extLst xmlns:a="http://schemas.openxmlformats.org/drawingml/2006/main">
               <a:ext uri="{FF2B5EF4-FFF2-40B4-BE49-F238E27FC236}">
-                <a16:creationId xmlns:a16="http://schemas.microsoft.com/office/drawing/2014/main" id="{5456AE56-51EC-4DD7-9D83-4381445E4DCB}"/>
+                <a16:creationId xmlns:a16="http://schemas.microsoft.com/office/drawing/2014/main" id="{7F7F81E1-5504-4500-9008-C60114E31D51}"/>
               </a:ext>
             </a:extLst>
           </p:cNvPr>
@@ -4181,7 +4275,7 @@
     </p:spTree>
     <p:extLst>
       <p:ext uri="{BB962C8B-B14F-4D97-AF65-F5344CB8AC3E}">
-        <p14:creationId xmlns:p14="http://schemas.microsoft.com/office/powerpoint/2010/main" val="1698710579"/>
+        <p14:creationId xmlns:p14="http://schemas.microsoft.com/office/powerpoint/2010/main" val="1192702466"/>
       </p:ext>
     </p:extLst>
   </p:cSld>
@@ -4212,7 +4306,7 @@
           <p:cNvPr id="4" name="">
             <a:extLst xmlns:a="http://schemas.openxmlformats.org/drawingml/2006/main">
               <a:ext uri="{FF2B5EF4-FFF2-40B4-BE49-F238E27FC236}">
-                <a16:creationId xmlns:a16="http://schemas.microsoft.com/office/drawing/2014/main" id="{1F53DF58-9F18-4387-9F41-5928E59DEF1E}"/>
+                <a16:creationId xmlns:a16="http://schemas.microsoft.com/office/drawing/2014/main" id="{1096AFED-798D-4A6C-91E4-40556F0852BE}"/>
               </a:ext>
             </a:extLst>
           </p:cNvPr>
@@ -4259,7 +4353,7 @@
                 <a:ea typeface="Helvetica Neue"/>
                 <a:cs typeface="Helvetica Neue"/>
               </a:rPr>
-              <a:t>離開教室前</a:t>
+              <a:t>AI 使用原則</a:t>
             </a:r>
           </a:p>
         </p:txBody>
@@ -4269,7 +4363,7 @@
           <p:cNvPr id="2" name="">
             <a:extLst xmlns:a="http://schemas.openxmlformats.org/drawingml/2006/main">
               <a:ext uri="{FF2B5EF4-FFF2-40B4-BE49-F238E27FC236}">
-                <a16:creationId xmlns:a16="http://schemas.microsoft.com/office/drawing/2014/main" id="{BCA2E98C-F1C0-42A5-8950-0F19DD8901BA}"/>
+                <a16:creationId xmlns:a16="http://schemas.microsoft.com/office/drawing/2014/main" id="{0F546DC1-92AF-4FC0-8740-BFED45999DE9}"/>
               </a:ext>
             </a:extLst>
           </p:cNvPr>
@@ -4316,7 +4410,7 @@
                 <a:ea typeface="Helvetica Neue"/>
                 <a:cs typeface="Helvetica Neue"/>
               </a:rPr>
-              <a:t>完成並儲存個人起點卡</a:t>
+              <a:t>AI 可以協助整理、翻譯與草擬問題。</a:t>
             </a:r>
           </a:p>
           <a:p xmlns:a="http://schemas.openxmlformats.org/drawingml/2006/main">
@@ -4339,58 +4433,7 @@
                 <a:ea typeface="Helvetica Neue"/>
                 <a:cs typeface="Helvetica Neue"/>
               </a:rPr>
-              <a:t>確認缺少欄位</a:t>
-            </a:r>
-          </a:p>
-          <a:p xmlns:a="http://schemas.openxmlformats.org/drawingml/2006/main">
-            <a:pPr>
-              <a:defRPr sz="1875">
-                <a:solidFill>
-                  <a:srgbClr val="263238"/>
-                </a:solidFill>
-                <a:latin typeface="Helvetica Neue"/>
-                <a:ea typeface="Helvetica Neue"/>
-                <a:cs typeface="Helvetica Neue"/>
-              </a:defRPr>
-            </a:pPr>
-            <a:r>
-              <a:rPr sz="1875">
-                <a:solidFill>
-                  <a:srgbClr val="263238"/>
-                </a:solidFill>
-                <a:latin typeface="Helvetica Neue"/>
-                <a:ea typeface="Helvetica Neue"/>
-                <a:cs typeface="Helvetica Neue"/>
-              </a:rPr>
-              <a:t>依教師指定方式提交</a:t>
-            </a:r>
-          </a:p>
-          <a:p xmlns:a="http://schemas.openxmlformats.org/drawingml/2006/main">
-            <a:r>
-              <a:t/>
-            </a:r>
-          </a:p>
-          <a:p xmlns:a="http://schemas.openxmlformats.org/drawingml/2006/main">
-            <a:pPr>
-              <a:defRPr sz="1875">
-                <a:solidFill>
-                  <a:srgbClr val="263238"/>
-                </a:solidFill>
-                <a:latin typeface="Helvetica Neue"/>
-                <a:ea typeface="Helvetica Neue"/>
-                <a:cs typeface="Helvetica Neue"/>
-              </a:defRPr>
-            </a:pPr>
-            <a:r>
-              <a:rPr sz="1875">
-                <a:solidFill>
-                  <a:srgbClr val="263238"/>
-                </a:solidFill>
-                <a:latin typeface="Helvetica Neue"/>
-                <a:ea typeface="Helvetica Neue"/>
-                <a:cs typeface="Helvetica Neue"/>
-              </a:rPr>
-              <a:t>下週：選擇一個問題，開始理解使用者</a:t>
+              <a:t>學生要保存原始觀察，查核 AI 的內容，不能捏造訪談或使用者資料。</a:t>
             </a:r>
           </a:p>
         </p:txBody>
@@ -4400,7 +4443,7 @@
           <p:cNvPr id="3" name="">
             <a:extLst xmlns:a="http://schemas.openxmlformats.org/drawingml/2006/main">
               <a:ext uri="{FF2B5EF4-FFF2-40B4-BE49-F238E27FC236}">
-                <a16:creationId xmlns:a16="http://schemas.microsoft.com/office/drawing/2014/main" id="{A321B58D-0B59-4478-BFD7-5F5DE3CADAA4}"/>
+                <a16:creationId xmlns:a16="http://schemas.microsoft.com/office/drawing/2014/main" id="{63391365-3F67-4616-B3FA-42A79B36F300}"/>
               </a:ext>
             </a:extLst>
           </p:cNvPr>
@@ -4455,7 +4498,281 @@
     </p:spTree>
     <p:extLst>
       <p:ext uri="{BB962C8B-B14F-4D97-AF65-F5344CB8AC3E}">
-        <p14:creationId xmlns:p14="http://schemas.microsoft.com/office/powerpoint/2010/main" val="2043765744"/>
+        <p14:creationId xmlns:p14="http://schemas.microsoft.com/office/powerpoint/2010/main" val="727983125"/>
+      </p:ext>
+    </p:extLst>
+  </p:cSld>
+</p:sld>
+</file>
+
+<file path=ppt/slides/slide18.xml><?xml version="1.0" encoding="utf-8"?>
+<p:sld xmlns:p="http://schemas.openxmlformats.org/presentationml/2006/main">
+  <p:cSld>
+    <p:bg>
+      <p:bgPr>
+        <a:solidFill xmlns:a="http://schemas.openxmlformats.org/drawingml/2006/main">
+          <a:srgbClr val="F7F4EE"/>
+        </a:solidFill>
+      </p:bgPr>
+    </p:bg>
+    <p:spTree>
+      <p:nvGrpSpPr>
+        <p:cNvPr id="1" name=""/>
+        <p:cNvGrpSpPr/>
+        <p:nvPr/>
+      </p:nvGrpSpPr>
+      <p:grpSpPr>
+        <a:xfrm xmlns:a="http://schemas.openxmlformats.org/drawingml/2006/main"/>
+      </p:grpSpPr>
+      <p:sp>
+        <p:nvSpPr>
+          <p:cNvPr id="4" name="">
+            <a:extLst xmlns:a="http://schemas.openxmlformats.org/drawingml/2006/main">
+              <a:ext uri="{FF2B5EF4-FFF2-40B4-BE49-F238E27FC236}">
+                <a16:creationId xmlns:a16="http://schemas.microsoft.com/office/drawing/2014/main" id="{D0456704-CC66-420A-B843-6B2654E48B5E}"/>
+              </a:ext>
+            </a:extLst>
+          </p:cNvPr>
+          <p:cNvSpPr>
+            <a:spLocks xmlns:a="http://schemas.openxmlformats.org/drawingml/2006/main" noGrp="1"/>
+          </p:cNvSpPr>
+          <p:nvPr/>
+        </p:nvSpPr>
+        <p:spPr>
+          <a:xfrm xmlns:a="http://schemas.openxmlformats.org/drawingml/2006/main">
+            <a:off x="800100" y="723900"/>
+            <a:ext cx="10572750" cy="857250"/>
+          </a:xfrm>
+          <a:prstGeom xmlns:a="http://schemas.openxmlformats.org/drawingml/2006/main" prst="rect">
+            <a:avLst/>
+          </a:prstGeom>
+          <a:noFill xmlns:a="http://schemas.openxmlformats.org/drawingml/2006/main"/>
+          <a:ln xmlns:a="http://schemas.openxmlformats.org/drawingml/2006/main" w="0">
+            <a:noFill/>
+          </a:ln>
+        </p:spPr>
+        <p:txBody>
+          <a:bodyPr xmlns:a="http://schemas.openxmlformats.org/drawingml/2006/main">
+            <a:normAutofit fontScale="100000"/>
+          </a:bodyPr>
+          <a:lstStyle xmlns:a="http://schemas.openxmlformats.org/drawingml/2006/main"/>
+          <a:p xmlns:a="http://schemas.openxmlformats.org/drawingml/2006/main">
+            <a:pPr>
+              <a:defRPr sz="2850" b="1">
+                <a:solidFill>
+                  <a:srgbClr val="143B4A"/>
+                </a:solidFill>
+                <a:latin typeface="Helvetica Neue"/>
+                <a:ea typeface="Helvetica Neue"/>
+                <a:cs typeface="Helvetica Neue"/>
+              </a:defRPr>
+            </a:pPr>
+            <a:r>
+              <a:rPr sz="2850" b="1">
+                <a:solidFill>
+                  <a:srgbClr val="143B4A"/>
+                </a:solidFill>
+                <a:latin typeface="Helvetica Neue"/>
+                <a:ea typeface="Helvetica Neue"/>
+                <a:cs typeface="Helvetica Neue"/>
+              </a:rPr>
+              <a:t>離開教室前</a:t>
+            </a:r>
+          </a:p>
+        </p:txBody>
+      </p:sp>
+      <p:sp>
+        <p:nvSpPr>
+          <p:cNvPr id="2" name="">
+            <a:extLst xmlns:a="http://schemas.openxmlformats.org/drawingml/2006/main">
+              <a:ext uri="{FF2B5EF4-FFF2-40B4-BE49-F238E27FC236}">
+                <a16:creationId xmlns:a16="http://schemas.microsoft.com/office/drawing/2014/main" id="{FEB2861D-3F8C-4D61-B08B-98D10CF8E784}"/>
+              </a:ext>
+            </a:extLst>
+          </p:cNvPr>
+          <p:cNvSpPr>
+            <a:spLocks xmlns:a="http://schemas.openxmlformats.org/drawingml/2006/main" noGrp="1"/>
+          </p:cNvSpPr>
+          <p:nvPr/>
+        </p:nvSpPr>
+        <p:spPr>
+          <a:xfrm xmlns:a="http://schemas.openxmlformats.org/drawingml/2006/main">
+            <a:off x="838200" y="2000250"/>
+            <a:ext cx="10001250" cy="3429000"/>
+          </a:xfrm>
+          <a:prstGeom xmlns:a="http://schemas.openxmlformats.org/drawingml/2006/main" prst="rect">
+            <a:avLst/>
+          </a:prstGeom>
+          <a:noFill xmlns:a="http://schemas.openxmlformats.org/drawingml/2006/main"/>
+          <a:ln xmlns:a="http://schemas.openxmlformats.org/drawingml/2006/main" w="0">
+            <a:noFill/>
+          </a:ln>
+        </p:spPr>
+        <p:txBody>
+          <a:bodyPr xmlns:a="http://schemas.openxmlformats.org/drawingml/2006/main">
+            <a:normAutofit fontScale="100000"/>
+          </a:bodyPr>
+          <a:lstStyle xmlns:a="http://schemas.openxmlformats.org/drawingml/2006/main"/>
+          <a:p xmlns:a="http://schemas.openxmlformats.org/drawingml/2006/main">
+            <a:pPr>
+              <a:defRPr sz="1875">
+                <a:solidFill>
+                  <a:srgbClr val="263238"/>
+                </a:solidFill>
+                <a:latin typeface="Helvetica Neue"/>
+                <a:ea typeface="Helvetica Neue"/>
+                <a:cs typeface="Helvetica Neue"/>
+              </a:defRPr>
+            </a:pPr>
+            <a:r>
+              <a:rPr sz="1875">
+                <a:solidFill>
+                  <a:srgbClr val="263238"/>
+                </a:solidFill>
+                <a:latin typeface="Helvetica Neue"/>
+                <a:ea typeface="Helvetica Neue"/>
+                <a:cs typeface="Helvetica Neue"/>
+              </a:rPr>
+              <a:t>完成並儲存個人起點卡</a:t>
+            </a:r>
+          </a:p>
+          <a:p xmlns:a="http://schemas.openxmlformats.org/drawingml/2006/main">
+            <a:pPr>
+              <a:defRPr sz="1875">
+                <a:solidFill>
+                  <a:srgbClr val="263238"/>
+                </a:solidFill>
+                <a:latin typeface="Helvetica Neue"/>
+                <a:ea typeface="Helvetica Neue"/>
+                <a:cs typeface="Helvetica Neue"/>
+              </a:defRPr>
+            </a:pPr>
+            <a:r>
+              <a:rPr sz="1875">
+                <a:solidFill>
+                  <a:srgbClr val="263238"/>
+                </a:solidFill>
+                <a:latin typeface="Helvetica Neue"/>
+                <a:ea typeface="Helvetica Neue"/>
+                <a:cs typeface="Helvetica Neue"/>
+              </a:rPr>
+              <a:t>確認缺少欄位</a:t>
+            </a:r>
+          </a:p>
+          <a:p xmlns:a="http://schemas.openxmlformats.org/drawingml/2006/main">
+            <a:pPr>
+              <a:defRPr sz="1875">
+                <a:solidFill>
+                  <a:srgbClr val="263238"/>
+                </a:solidFill>
+                <a:latin typeface="Helvetica Neue"/>
+                <a:ea typeface="Helvetica Neue"/>
+                <a:cs typeface="Helvetica Neue"/>
+              </a:defRPr>
+            </a:pPr>
+            <a:r>
+              <a:rPr sz="1875">
+                <a:solidFill>
+                  <a:srgbClr val="263238"/>
+                </a:solidFill>
+                <a:latin typeface="Helvetica Neue"/>
+                <a:ea typeface="Helvetica Neue"/>
+                <a:cs typeface="Helvetica Neue"/>
+              </a:rPr>
+              <a:t>依教師指定方式提交</a:t>
+            </a:r>
+          </a:p>
+          <a:p xmlns:a="http://schemas.openxmlformats.org/drawingml/2006/main">
+            <a:r>
+              <a:t/>
+            </a:r>
+          </a:p>
+          <a:p xmlns:a="http://schemas.openxmlformats.org/drawingml/2006/main">
+            <a:pPr>
+              <a:defRPr sz="1875">
+                <a:solidFill>
+                  <a:srgbClr val="263238"/>
+                </a:solidFill>
+                <a:latin typeface="Helvetica Neue"/>
+                <a:ea typeface="Helvetica Neue"/>
+                <a:cs typeface="Helvetica Neue"/>
+              </a:defRPr>
+            </a:pPr>
+            <a:r>
+              <a:rPr sz="1875">
+                <a:solidFill>
+                  <a:srgbClr val="263238"/>
+                </a:solidFill>
+                <a:latin typeface="Helvetica Neue"/>
+                <a:ea typeface="Helvetica Neue"/>
+                <a:cs typeface="Helvetica Neue"/>
+              </a:rPr>
+              <a:t>下週：選擇一個問題，開始理解使用者</a:t>
+            </a:r>
+          </a:p>
+        </p:txBody>
+      </p:sp>
+      <p:sp>
+        <p:nvSpPr>
+          <p:cNvPr id="3" name="">
+            <a:extLst xmlns:a="http://schemas.openxmlformats.org/drawingml/2006/main">
+              <a:ext uri="{FF2B5EF4-FFF2-40B4-BE49-F238E27FC236}">
+                <a16:creationId xmlns:a16="http://schemas.microsoft.com/office/drawing/2014/main" id="{78A0165D-2AD7-420A-97C7-B87E484CBE43}"/>
+              </a:ext>
+            </a:extLst>
+          </p:cNvPr>
+          <p:cNvSpPr>
+            <a:spLocks xmlns:a="http://schemas.openxmlformats.org/drawingml/2006/main" noGrp="1"/>
+          </p:cNvSpPr>
+          <p:nvPr/>
+        </p:nvSpPr>
+        <p:spPr>
+          <a:xfrm xmlns:a="http://schemas.openxmlformats.org/drawingml/2006/main">
+            <a:off x="838200" y="6143625"/>
+            <a:ext cx="10287000" cy="266700"/>
+          </a:xfrm>
+          <a:prstGeom xmlns:a="http://schemas.openxmlformats.org/drawingml/2006/main" prst="rect">
+            <a:avLst/>
+          </a:prstGeom>
+          <a:noFill xmlns:a="http://schemas.openxmlformats.org/drawingml/2006/main"/>
+          <a:ln xmlns:a="http://schemas.openxmlformats.org/drawingml/2006/main" w="0">
+            <a:noFill/>
+          </a:ln>
+        </p:spPr>
+        <p:txBody>
+          <a:bodyPr xmlns:a="http://schemas.openxmlformats.org/drawingml/2006/main">
+            <a:normAutofit fontScale="100000"/>
+          </a:bodyPr>
+          <a:lstStyle xmlns:a="http://schemas.openxmlformats.org/drawingml/2006/main"/>
+          <a:p xmlns:a="http://schemas.openxmlformats.org/drawingml/2006/main">
+            <a:pPr>
+              <a:defRPr sz="1050">
+                <a:solidFill>
+                  <a:srgbClr val="52726C"/>
+                </a:solidFill>
+                <a:latin typeface="Helvetica Neue"/>
+                <a:ea typeface="Helvetica Neue"/>
+                <a:cs typeface="Helvetica Neue"/>
+              </a:defRPr>
+            </a:pPr>
+            <a:r>
+              <a:rPr sz="1050">
+                <a:solidFill>
+                  <a:srgbClr val="52726C"/>
+                </a:solidFill>
+                <a:latin typeface="Helvetica Neue"/>
+                <a:ea typeface="Helvetica Neue"/>
+                <a:cs typeface="Helvetica Neue"/>
+              </a:rPr>
+              <a:t>Startup Journey Lab  •  Week 1  •  18</a:t>
+            </a:r>
+          </a:p>
+        </p:txBody>
+      </p:sp>
+    </p:spTree>
+    <p:extLst>
+      <p:ext uri="{BB962C8B-B14F-4D97-AF65-F5344CB8AC3E}">
+        <p14:creationId xmlns:p14="http://schemas.microsoft.com/office/powerpoint/2010/main" val="374841332"/>
       </p:ext>
     </p:extLst>
   </p:cSld>
@@ -4486,7 +4803,7 @@
           <p:cNvPr id="4" name="">
             <a:extLst xmlns:a="http://schemas.openxmlformats.org/drawingml/2006/main">
               <a:ext uri="{FF2B5EF4-FFF2-40B4-BE49-F238E27FC236}">
-                <a16:creationId xmlns:a16="http://schemas.microsoft.com/office/drawing/2014/main" id="{3F75E0AE-ECE0-4701-B692-E330B4C7D72E}"/>
+                <a16:creationId xmlns:a16="http://schemas.microsoft.com/office/drawing/2014/main" id="{50333CDA-B6A8-4A08-A897-86529CC53CAD}"/>
               </a:ext>
             </a:extLst>
           </p:cNvPr>
@@ -4543,7 +4860,7 @@
           <p:cNvPr id="2" name="">
             <a:extLst xmlns:a="http://schemas.openxmlformats.org/drawingml/2006/main">
               <a:ext uri="{FF2B5EF4-FFF2-40B4-BE49-F238E27FC236}">
-                <a16:creationId xmlns:a16="http://schemas.microsoft.com/office/drawing/2014/main" id="{5BE436D2-248E-438E-ACB8-DE9963743E5B}"/>
+                <a16:creationId xmlns:a16="http://schemas.microsoft.com/office/drawing/2014/main" id="{7A4AE541-B60E-458A-8B96-02CD89F44646}"/>
               </a:ext>
             </a:extLst>
           </p:cNvPr>
@@ -4669,7 +4986,7 @@
           <p:cNvPr id="3" name="">
             <a:extLst xmlns:a="http://schemas.openxmlformats.org/drawingml/2006/main">
               <a:ext uri="{FF2B5EF4-FFF2-40B4-BE49-F238E27FC236}">
-                <a16:creationId xmlns:a16="http://schemas.microsoft.com/office/drawing/2014/main" id="{7C449704-BBC9-472B-B0DA-659F0B63CAEE}"/>
+                <a16:creationId xmlns:a16="http://schemas.microsoft.com/office/drawing/2014/main" id="{40EFA037-C9DC-4101-B7C0-51E97729EFA1}"/>
               </a:ext>
             </a:extLst>
           </p:cNvPr>
@@ -4724,7 +5041,7 @@
     </p:spTree>
     <p:extLst>
       <p:ext uri="{BB962C8B-B14F-4D97-AF65-F5344CB8AC3E}">
-        <p14:creationId xmlns:p14="http://schemas.microsoft.com/office/powerpoint/2010/main" val="882139077"/>
+        <p14:creationId xmlns:p14="http://schemas.microsoft.com/office/powerpoint/2010/main" val="788785481"/>
       </p:ext>
     </p:extLst>
   </p:cSld>
@@ -4755,7 +5072,7 @@
           <p:cNvPr id="4" name="">
             <a:extLst xmlns:a="http://schemas.openxmlformats.org/drawingml/2006/main">
               <a:ext uri="{FF2B5EF4-FFF2-40B4-BE49-F238E27FC236}">
-                <a16:creationId xmlns:a16="http://schemas.microsoft.com/office/drawing/2014/main" id="{3861324D-3EE0-4484-B67A-DA71B316452C}"/>
+                <a16:creationId xmlns:a16="http://schemas.microsoft.com/office/drawing/2014/main" id="{F04D3AC8-785F-4A31-B84C-D93AA155DA4E}"/>
               </a:ext>
             </a:extLst>
           </p:cNvPr>
@@ -4812,7 +5129,7 @@
           <p:cNvPr id="2" name="">
             <a:extLst xmlns:a="http://schemas.openxmlformats.org/drawingml/2006/main">
               <a:ext uri="{FF2B5EF4-FFF2-40B4-BE49-F238E27FC236}">
-                <a16:creationId xmlns:a16="http://schemas.microsoft.com/office/drawing/2014/main" id="{81ADDE66-180D-4B15-9976-DAFBFE8847A2}"/>
+                <a16:creationId xmlns:a16="http://schemas.microsoft.com/office/drawing/2014/main" id="{4A3815ED-D014-4803-9483-5A9B776E8456}"/>
               </a:ext>
             </a:extLst>
           </p:cNvPr>
@@ -4915,7 +5232,7 @@
           <p:cNvPr id="3" name="">
             <a:extLst xmlns:a="http://schemas.openxmlformats.org/drawingml/2006/main">
               <a:ext uri="{FF2B5EF4-FFF2-40B4-BE49-F238E27FC236}">
-                <a16:creationId xmlns:a16="http://schemas.microsoft.com/office/drawing/2014/main" id="{5E882F75-5210-45D8-9FCA-5241A402821E}"/>
+                <a16:creationId xmlns:a16="http://schemas.microsoft.com/office/drawing/2014/main" id="{E53A0D92-2101-43EA-B82A-A02A5459637E}"/>
               </a:ext>
             </a:extLst>
           </p:cNvPr>
@@ -4970,7 +5287,7 @@
     </p:spTree>
     <p:extLst>
       <p:ext uri="{BB962C8B-B14F-4D97-AF65-F5344CB8AC3E}">
-        <p14:creationId xmlns:p14="http://schemas.microsoft.com/office/powerpoint/2010/main" val="674941101"/>
+        <p14:creationId xmlns:p14="http://schemas.microsoft.com/office/powerpoint/2010/main" val="523274595"/>
       </p:ext>
     </p:extLst>
   </p:cSld>
@@ -5001,7 +5318,7 @@
           <p:cNvPr id="4" name="">
             <a:extLst xmlns:a="http://schemas.openxmlformats.org/drawingml/2006/main">
               <a:ext uri="{FF2B5EF4-FFF2-40B4-BE49-F238E27FC236}">
-                <a16:creationId xmlns:a16="http://schemas.microsoft.com/office/drawing/2014/main" id="{8BBFB220-2CE8-4E56-ADF3-8717414B08D8}"/>
+                <a16:creationId xmlns:a16="http://schemas.microsoft.com/office/drawing/2014/main" id="{CFA05F45-DD30-437D-AD4E-34C4D53C8A00}"/>
               </a:ext>
             </a:extLst>
           </p:cNvPr>
@@ -5048,7 +5365,7 @@
                 <a:ea typeface="Helvetica Neue"/>
                 <a:cs typeface="Helvetica Neue"/>
               </a:rPr>
-              <a:t>Week 1 核心影片</a:t>
+              <a:t>Week 1 的五個重點</a:t>
             </a:r>
           </a:p>
         </p:txBody>
@@ -5058,7 +5375,7 @@
           <p:cNvPr id="2" name="">
             <a:extLst xmlns:a="http://schemas.openxmlformats.org/drawingml/2006/main">
               <a:ext uri="{FF2B5EF4-FFF2-40B4-BE49-F238E27FC236}">
-                <a16:creationId xmlns:a16="http://schemas.microsoft.com/office/drawing/2014/main" id="{61AAF2D6-DF2B-4042-A4CA-7FC87539927D}"/>
+                <a16:creationId xmlns:a16="http://schemas.microsoft.com/office/drawing/2014/main" id="{51F0528F-5643-46DB-9674-95DF5FA80854}"/>
               </a:ext>
             </a:extLst>
           </p:cNvPr>
@@ -5105,7 +5422,7 @@
                 <a:ea typeface="Helvetica Neue"/>
                 <a:cs typeface="Helvetica Neue"/>
               </a:rPr>
-              <a:t>Should You Start A Startup?</a:t>
+              <a:t>1. 創業不是職稱，而是持續解決問題的選擇。</a:t>
             </a:r>
           </a:p>
           <a:p xmlns:a="http://schemas.openxmlformats.org/drawingml/2006/main">
@@ -5128,12 +5445,7 @@
                 <a:ea typeface="Helvetica Neue"/>
                 <a:cs typeface="Helvetica Neue"/>
               </a:rPr>
-              <a:t>Y Combinator Startup School</a:t>
-            </a:r>
-          </a:p>
-          <a:p xmlns:a="http://schemas.openxmlformats.org/drawingml/2006/main">
-            <a:r>
-              <a:t/>
+              <a:t>2. 先理解困擾，再想產品。</a:t>
             </a:r>
           </a:p>
           <a:p xmlns:a="http://schemas.openxmlformats.org/drawingml/2006/main">
@@ -5156,7 +5468,7 @@
                 <a:ea typeface="Helvetica Neue"/>
                 <a:cs typeface="Helvetica Neue"/>
               </a:rPr>
-              <a:t>今天的問題不是「我的點子夠不夠厲害？」</a:t>
+              <a:t>3. 動機必須能承受不確定與反覆修改。</a:t>
             </a:r>
           </a:p>
           <a:p xmlns:a="http://schemas.openxmlformats.org/drawingml/2006/main">
@@ -5179,7 +5491,30 @@
                 <a:ea typeface="Helvetica Neue"/>
                 <a:cs typeface="Helvetica Neue"/>
               </a:rPr>
-              <a:t>而是「我是否真的理解一個值得持續研究的問題？」</a:t>
+              <a:t>4. 小而具體的觀察，比「大市場點子」更適合作為起點。</a:t>
+            </a:r>
+          </a:p>
+          <a:p xmlns:a="http://schemas.openxmlformats.org/drawingml/2006/main">
+            <a:pPr>
+              <a:defRPr sz="1875">
+                <a:solidFill>
+                  <a:srgbClr val="263238"/>
+                </a:solidFill>
+                <a:latin typeface="Helvetica Neue"/>
+                <a:ea typeface="Helvetica Neue"/>
+                <a:cs typeface="Helvetica Neue"/>
+              </a:defRPr>
+            </a:pPr>
+            <a:r>
+              <a:rPr sz="1875">
+                <a:solidFill>
+                  <a:srgbClr val="263238"/>
+                </a:solidFill>
+                <a:latin typeface="Helvetica Neue"/>
+                <a:ea typeface="Helvetica Neue"/>
+                <a:cs typeface="Helvetica Neue"/>
+              </a:rPr>
+              <a:t>5. 第一週的成功標準是提出好問題，不是提出好解法。</a:t>
             </a:r>
           </a:p>
         </p:txBody>
@@ -5189,7 +5524,7 @@
           <p:cNvPr id="3" name="">
             <a:extLst xmlns:a="http://schemas.openxmlformats.org/drawingml/2006/main">
               <a:ext uri="{FF2B5EF4-FFF2-40B4-BE49-F238E27FC236}">
-                <a16:creationId xmlns:a16="http://schemas.microsoft.com/office/drawing/2014/main" id="{3A951E41-2C12-4655-B2E1-71930FDF0839}"/>
+                <a16:creationId xmlns:a16="http://schemas.microsoft.com/office/drawing/2014/main" id="{F93CE210-E490-44CF-8708-06C5D189F1B1}"/>
               </a:ext>
             </a:extLst>
           </p:cNvPr>
@@ -5244,7 +5579,7 @@
     </p:spTree>
     <p:extLst>
       <p:ext uri="{BB962C8B-B14F-4D97-AF65-F5344CB8AC3E}">
-        <p14:creationId xmlns:p14="http://schemas.microsoft.com/office/powerpoint/2010/main" val="1049603907"/>
+        <p14:creationId xmlns:p14="http://schemas.microsoft.com/office/powerpoint/2010/main" val="296256067"/>
       </p:ext>
     </p:extLst>
   </p:cSld>
@@ -5275,7 +5610,7 @@
           <p:cNvPr id="4" name="">
             <a:extLst xmlns:a="http://schemas.openxmlformats.org/drawingml/2006/main">
               <a:ext uri="{FF2B5EF4-FFF2-40B4-BE49-F238E27FC236}">
-                <a16:creationId xmlns:a16="http://schemas.microsoft.com/office/drawing/2014/main" id="{7C83EE86-BFF7-4B3C-9DDC-66CB10261FE4}"/>
+                <a16:creationId xmlns:a16="http://schemas.microsoft.com/office/drawing/2014/main" id="{96046B02-D0A7-449D-933B-9A7F66D28474}"/>
               </a:ext>
             </a:extLst>
           </p:cNvPr>
@@ -5322,7 +5657,7 @@
                 <a:ea typeface="Helvetica Neue"/>
                 <a:cs typeface="Helvetica Neue"/>
               </a:rPr>
-              <a:t>影片想問你的問題</a:t>
+              <a:t>Week 1 核心影片</a:t>
             </a:r>
           </a:p>
         </p:txBody>
@@ -5332,7 +5667,7 @@
           <p:cNvPr id="2" name="">
             <a:extLst xmlns:a="http://schemas.openxmlformats.org/drawingml/2006/main">
               <a:ext uri="{FF2B5EF4-FFF2-40B4-BE49-F238E27FC236}">
-                <a16:creationId xmlns:a16="http://schemas.microsoft.com/office/drawing/2014/main" id="{0D056AC4-E87D-425B-B42E-02FDE983314F}"/>
+                <a16:creationId xmlns:a16="http://schemas.microsoft.com/office/drawing/2014/main" id="{CC8AC1DC-BD92-4EE3-B3B6-0B8134DB1606}"/>
               </a:ext>
             </a:extLst>
           </p:cNvPr>
@@ -5379,7 +5714,7 @@
                 <a:ea typeface="Helvetica Neue"/>
                 <a:cs typeface="Helvetica Neue"/>
               </a:rPr>
-              <a:t>我是否真的想理解並持續處理一個問題？</a:t>
+              <a:t>Should You Start A Startup?</a:t>
             </a:r>
           </a:p>
           <a:p xmlns:a="http://schemas.openxmlformats.org/drawingml/2006/main">
@@ -5402,7 +5737,7 @@
                 <a:ea typeface="Helvetica Neue"/>
                 <a:cs typeface="Helvetica Neue"/>
               </a:rPr>
-              <a:t>而不是只想快速有一個產品、公司名稱或很酷的點子。</a:t>
+              <a:t>Y Combinator Startup School</a:t>
             </a:r>
           </a:p>
           <a:p xmlns:a="http://schemas.openxmlformats.org/drawingml/2006/main">
@@ -5430,7 +5765,30 @@
                 <a:ea typeface="Helvetica Neue"/>
                 <a:cs typeface="Helvetica Neue"/>
               </a:rPr>
-              <a:t>Week 1 不需要決定你會不會創業。</a:t>
+              <a:t>今天的問題不是「我的點子夠不夠厲害？」</a:t>
+            </a:r>
+          </a:p>
+          <a:p xmlns:a="http://schemas.openxmlformats.org/drawingml/2006/main">
+            <a:pPr>
+              <a:defRPr sz="1875">
+                <a:solidFill>
+                  <a:srgbClr val="263238"/>
+                </a:solidFill>
+                <a:latin typeface="Helvetica Neue"/>
+                <a:ea typeface="Helvetica Neue"/>
+                <a:cs typeface="Helvetica Neue"/>
+              </a:defRPr>
+            </a:pPr>
+            <a:r>
+              <a:rPr sz="1875">
+                <a:solidFill>
+                  <a:srgbClr val="263238"/>
+                </a:solidFill>
+                <a:latin typeface="Helvetica Neue"/>
+                <a:ea typeface="Helvetica Neue"/>
+                <a:cs typeface="Helvetica Neue"/>
+              </a:rPr>
+              <a:t>而是「我是否真的理解一個值得持續研究的問題？」</a:t>
             </a:r>
           </a:p>
         </p:txBody>
@@ -5440,7 +5798,7 @@
           <p:cNvPr id="3" name="">
             <a:extLst xmlns:a="http://schemas.openxmlformats.org/drawingml/2006/main">
               <a:ext uri="{FF2B5EF4-FFF2-40B4-BE49-F238E27FC236}">
-                <a16:creationId xmlns:a16="http://schemas.microsoft.com/office/drawing/2014/main" id="{EE100CE4-4875-4922-8932-29A09725C51C}"/>
+                <a16:creationId xmlns:a16="http://schemas.microsoft.com/office/drawing/2014/main" id="{B112D2D4-F431-4292-A315-9E9F720F8448}"/>
               </a:ext>
             </a:extLst>
           </p:cNvPr>
@@ -5495,7 +5853,7 @@
     </p:spTree>
     <p:extLst>
       <p:ext uri="{BB962C8B-B14F-4D97-AF65-F5344CB8AC3E}">
-        <p14:creationId xmlns:p14="http://schemas.microsoft.com/office/powerpoint/2010/main" val="1095178927"/>
+        <p14:creationId xmlns:p14="http://schemas.microsoft.com/office/powerpoint/2010/main" val="250687744"/>
       </p:ext>
     </p:extLst>
   </p:cSld>
@@ -5526,7 +5884,7 @@
           <p:cNvPr id="4" name="">
             <a:extLst xmlns:a="http://schemas.openxmlformats.org/drawingml/2006/main">
               <a:ext uri="{FF2B5EF4-FFF2-40B4-BE49-F238E27FC236}">
-                <a16:creationId xmlns:a16="http://schemas.microsoft.com/office/drawing/2014/main" id="{86968DD9-5712-45DC-BBAD-D41A22A10F79}"/>
+                <a16:creationId xmlns:a16="http://schemas.microsoft.com/office/drawing/2014/main" id="{4D7FA675-5FE5-425E-B24E-5CD3E69667CF}"/>
               </a:ext>
             </a:extLst>
           </p:cNvPr>
@@ -5573,7 +5931,7 @@
                 <a:ea typeface="Helvetica Neue"/>
                 <a:cs typeface="Helvetica Neue"/>
               </a:rPr>
-              <a:t>先理解問題，再提出解法</a:t>
+              <a:t>影片想問你的問題</a:t>
             </a:r>
           </a:p>
         </p:txBody>
@@ -5583,7 +5941,7 @@
           <p:cNvPr id="2" name="">
             <a:extLst xmlns:a="http://schemas.openxmlformats.org/drawingml/2006/main">
               <a:ext uri="{FF2B5EF4-FFF2-40B4-BE49-F238E27FC236}">
-                <a16:creationId xmlns:a16="http://schemas.microsoft.com/office/drawing/2014/main" id="{EB3D89B4-EA6A-43E6-88B5-DA71A3B0F86F}"/>
+                <a16:creationId xmlns:a16="http://schemas.microsoft.com/office/drawing/2014/main" id="{B78F6241-145D-4539-A60D-B7505D06F062}"/>
               </a:ext>
             </a:extLst>
           </p:cNvPr>
@@ -5630,7 +5988,7 @@
                 <a:ea typeface="Helvetica Neue"/>
                 <a:cs typeface="Helvetica Neue"/>
               </a:rPr>
-              <a:t>太早想出 App，容易只找支持自己想法的證據。</a:t>
+              <a:t>我是否真的想理解並持續處理一個問題？</a:t>
             </a:r>
           </a:p>
           <a:p xmlns:a="http://schemas.openxmlformats.org/drawingml/2006/main">
@@ -5653,7 +6011,12 @@
                 <a:ea typeface="Helvetica Neue"/>
                 <a:cs typeface="Helvetica Neue"/>
               </a:rPr>
-              <a:t>先寫下使用者原句、現場與目前做法。</a:t>
+              <a:t>而不是只想快速有一個產品、公司名稱或很酷的點子。</a:t>
+            </a:r>
+          </a:p>
+          <a:p xmlns:a="http://schemas.openxmlformats.org/drawingml/2006/main">
+            <a:r>
+              <a:t/>
             </a:r>
           </a:p>
           <a:p xmlns:a="http://schemas.openxmlformats.org/drawingml/2006/main">
@@ -5676,7 +6039,7 @@
                 <a:ea typeface="Helvetica Neue"/>
                 <a:cs typeface="Helvetica Neue"/>
               </a:rPr>
-              <a:t>Week 3 才用訪談確認你的猜測。</a:t>
+              <a:t>Week 1 不需要決定你會不會創業。</a:t>
             </a:r>
           </a:p>
         </p:txBody>
@@ -5686,7 +6049,7 @@
           <p:cNvPr id="3" name="">
             <a:extLst xmlns:a="http://schemas.openxmlformats.org/drawingml/2006/main">
               <a:ext uri="{FF2B5EF4-FFF2-40B4-BE49-F238E27FC236}">
-                <a16:creationId xmlns:a16="http://schemas.microsoft.com/office/drawing/2014/main" id="{65D6BBB8-0F0B-46B4-ADA3-9ED9D899583F}"/>
+                <a16:creationId xmlns:a16="http://schemas.microsoft.com/office/drawing/2014/main" id="{0402F892-684F-4B09-877D-58C3F0F59BB0}"/>
               </a:ext>
             </a:extLst>
           </p:cNvPr>
@@ -5741,7 +6104,7 @@
     </p:spTree>
     <p:extLst>
       <p:ext uri="{BB962C8B-B14F-4D97-AF65-F5344CB8AC3E}">
-        <p14:creationId xmlns:p14="http://schemas.microsoft.com/office/powerpoint/2010/main" val="477064903"/>
+        <p14:creationId xmlns:p14="http://schemas.microsoft.com/office/powerpoint/2010/main" val="1715594993"/>
       </p:ext>
     </p:extLst>
   </p:cSld>
@@ -5772,7 +6135,7 @@
           <p:cNvPr id="4" name="">
             <a:extLst xmlns:a="http://schemas.openxmlformats.org/drawingml/2006/main">
               <a:ext uri="{FF2B5EF4-FFF2-40B4-BE49-F238E27FC236}">
-                <a16:creationId xmlns:a16="http://schemas.microsoft.com/office/drawing/2014/main" id="{EBCB06D7-BB11-4752-A9DD-56E150EF1F5C}"/>
+                <a16:creationId xmlns:a16="http://schemas.microsoft.com/office/drawing/2014/main" id="{A3541F0F-8E3E-4B2E-98AB-6C235B404A65}"/>
               </a:ext>
             </a:extLst>
           </p:cNvPr>
@@ -5819,7 +6182,7 @@
                 <a:ea typeface="Helvetica Neue"/>
                 <a:cs typeface="Helvetica Neue"/>
               </a:rPr>
-              <a:t>小而具體的觀察就能開始</a:t>
+              <a:t>先理解問題，再提出解法</a:t>
             </a:r>
           </a:p>
         </p:txBody>
@@ -5829,7 +6192,7 @@
           <p:cNvPr id="2" name="">
             <a:extLst xmlns:a="http://schemas.openxmlformats.org/drawingml/2006/main">
               <a:ext uri="{FF2B5EF4-FFF2-40B4-BE49-F238E27FC236}">
-                <a16:creationId xmlns:a16="http://schemas.microsoft.com/office/drawing/2014/main" id="{706B660F-7F99-4FB8-96C4-3BC6079CC514}"/>
+                <a16:creationId xmlns:a16="http://schemas.microsoft.com/office/drawing/2014/main" id="{905C4464-77DF-4D66-80F5-651EB3B4A5B7}"/>
               </a:ext>
             </a:extLst>
           </p:cNvPr>
@@ -5876,7 +6239,7 @@
                 <a:ea typeface="Helvetica Neue"/>
                 <a:cs typeface="Helvetica Neue"/>
               </a:rPr>
-              <a:t>不是：我想做校園外送平台。</a:t>
+              <a:t>太早想出 App，容易只找支持自己想法的證據。</a:t>
             </a:r>
           </a:p>
           <a:p xmlns:a="http://schemas.openxmlformats.org/drawingml/2006/main">
@@ -5899,12 +6262,7 @@
                 <a:ea typeface="Helvetica Neue"/>
                 <a:cs typeface="Helvetica Neue"/>
               </a:rPr>
-              <a:t>而是：中午只有 50 分鐘空檔的學生，常因排隊太久放棄吃午餐。</a:t>
-            </a:r>
-          </a:p>
-          <a:p xmlns:a="http://schemas.openxmlformats.org/drawingml/2006/main">
-            <a:r>
-              <a:t/>
+              <a:t>先寫下使用者原句、現場與目前做法。</a:t>
             </a:r>
           </a:p>
           <a:p xmlns:a="http://schemas.openxmlformats.org/drawingml/2006/main">
@@ -5927,7 +6285,7 @@
                 <a:ea typeface="Helvetica Neue"/>
                 <a:cs typeface="Helvetica Neue"/>
               </a:rPr>
-              <a:t>說清楚誰、何時、在哪裡、發生什麼事。</a:t>
+              <a:t>Week 3 才用訪談確認你的猜測。</a:t>
             </a:r>
           </a:p>
         </p:txBody>
@@ -5937,7 +6295,7 @@
           <p:cNvPr id="3" name="">
             <a:extLst xmlns:a="http://schemas.openxmlformats.org/drawingml/2006/main">
               <a:ext uri="{FF2B5EF4-FFF2-40B4-BE49-F238E27FC236}">
-                <a16:creationId xmlns:a16="http://schemas.microsoft.com/office/drawing/2014/main" id="{7A4AAA01-C85A-40BA-8A47-94A865F0E825}"/>
+                <a16:creationId xmlns:a16="http://schemas.microsoft.com/office/drawing/2014/main" id="{C6BB3362-0F8D-4A78-842C-D83CEF37894B}"/>
               </a:ext>
             </a:extLst>
           </p:cNvPr>
@@ -5992,7 +6350,7 @@
     </p:spTree>
     <p:extLst>
       <p:ext uri="{BB962C8B-B14F-4D97-AF65-F5344CB8AC3E}">
-        <p14:creationId xmlns:p14="http://schemas.microsoft.com/office/powerpoint/2010/main" val="1526389518"/>
+        <p14:creationId xmlns:p14="http://schemas.microsoft.com/office/powerpoint/2010/main" val="87692507"/>
       </p:ext>
     </p:extLst>
   </p:cSld>
@@ -6027,7 +6385,7 @@
           <p:nvPr/>
         </p:nvPicPr>
         <p:blipFill>
-          <a:blip xmlns:r="http://schemas.openxmlformats.org/officeDocument/2006/relationships" xmlns:a="http://schemas.openxmlformats.org/drawingml/2006/main" r:embed="Rd2f99393859349eb"/>
+          <a:blip xmlns:r="http://schemas.openxmlformats.org/officeDocument/2006/relationships" xmlns:a="http://schemas.openxmlformats.org/drawingml/2006/main" r:embed="R691b8891e06c470c"/>
           <a:srcRect xmlns:a="http://schemas.openxmlformats.org/drawingml/2006/main" l="24930" t="0" r="24930" b="0"/>
           <a:stretch xmlns:a="http://schemas.openxmlformats.org/drawingml/2006/main">
             <a:fillRect l="0" t="0" r="0" b="0"/>
@@ -6050,7 +6408,7 @@
           <p:cNvPr id="2" name="">
             <a:extLst xmlns:a="http://schemas.openxmlformats.org/drawingml/2006/main">
               <a:ext uri="{FF2B5EF4-FFF2-40B4-BE49-F238E27FC236}">
-                <a16:creationId xmlns:a16="http://schemas.microsoft.com/office/drawing/2014/main" id="{988E7779-B4D4-432A-B3B3-3B1F1BA760D6}"/>
+                <a16:creationId xmlns:a16="http://schemas.microsoft.com/office/drawing/2014/main" id="{6DABCFD4-4FB3-45C6-9025-5FB0B7619839}"/>
               </a:ext>
             </a:extLst>
           </p:cNvPr>
@@ -6097,7 +6455,7 @@
                 <a:ea typeface="Helvetica Neue"/>
                 <a:cs typeface="Helvetica Neue"/>
               </a:rPr>
-              <a:t>影片重點一：從真實問題開始</a:t>
+              <a:t>小而具體的觀察就能開始</a:t>
             </a:r>
           </a:p>
         </p:txBody>
@@ -6107,7 +6465,7 @@
           <p:cNvPr id="3" name="">
             <a:extLst xmlns:a="http://schemas.openxmlformats.org/drawingml/2006/main">
               <a:ext uri="{FF2B5EF4-FFF2-40B4-BE49-F238E27FC236}">
-                <a16:creationId xmlns:a16="http://schemas.microsoft.com/office/drawing/2014/main" id="{B5FA4F94-EF1A-412D-AA3F-820008BAE2E7}"/>
+                <a16:creationId xmlns:a16="http://schemas.microsoft.com/office/drawing/2014/main" id="{03C9BD58-4B71-4633-A72A-AB7ADBA8F130}"/>
               </a:ext>
             </a:extLst>
           </p:cNvPr>
@@ -6154,7 +6512,7 @@
                 <a:ea typeface="Helvetica Neue"/>
                 <a:cs typeface="Helvetica Neue"/>
               </a:rPr>
-              <a:t>創業的起點是你願意長期處理的問題。</a:t>
+              <a:t>不是：我想做校園外送平台。</a:t>
             </a:r>
           </a:p>
           <a:p xmlns:a="http://schemas.openxmlformats.org/drawingml/2006/main">
@@ -6177,7 +6535,12 @@
                 <a:ea typeface="Helvetica Neue"/>
                 <a:cs typeface="Helvetica Neue"/>
               </a:rPr>
-              <a:t>先觀察具體情境與受到影響的人。</a:t>
+              <a:t>而是：中午只有 50 分鐘空檔的學生，常因排隊太久放棄吃午餐。</a:t>
+            </a:r>
+          </a:p>
+          <a:p xmlns:a="http://schemas.openxmlformats.org/drawingml/2006/main">
+            <a:r>
+              <a:t/>
             </a:r>
           </a:p>
           <a:p xmlns:a="http://schemas.openxmlformats.org/drawingml/2006/main">
@@ -6200,7 +6563,7 @@
                 <a:ea typeface="Helvetica Neue"/>
                 <a:cs typeface="Helvetica Neue"/>
               </a:rPr>
-              <a:t>不要只因為某個點子聽起來很新或很像成功案例。</a:t>
+              <a:t>說清楚誰、何時、在哪裡、發生什麼事。</a:t>
             </a:r>
           </a:p>
         </p:txBody>
@@ -6210,7 +6573,7 @@
           <p:cNvPr id="4" name="">
             <a:extLst xmlns:a="http://schemas.openxmlformats.org/drawingml/2006/main">
               <a:ext uri="{FF2B5EF4-FFF2-40B4-BE49-F238E27FC236}">
-                <a16:creationId xmlns:a16="http://schemas.microsoft.com/office/drawing/2014/main" id="{E59297A8-2315-415D-9FE9-C447E338CE50}"/>
+                <a16:creationId xmlns:a16="http://schemas.microsoft.com/office/drawing/2014/main" id="{359B49EE-36DB-4F03-93B6-3A14CBB93B47}"/>
               </a:ext>
             </a:extLst>
           </p:cNvPr>
@@ -6265,7 +6628,7 @@
     </p:spTree>
     <p:extLst>
       <p:ext uri="{BB962C8B-B14F-4D97-AF65-F5344CB8AC3E}">
-        <p14:creationId xmlns:p14="http://schemas.microsoft.com/office/powerpoint/2010/main" val="967052797"/>
+        <p14:creationId xmlns:p14="http://schemas.microsoft.com/office/powerpoint/2010/main" val="1847453977"/>
       </p:ext>
     </p:extLst>
   </p:cSld>
@@ -6300,7 +6663,7 @@
           <p:nvPr/>
         </p:nvPicPr>
         <p:blipFill>
-          <a:blip xmlns:r="http://schemas.openxmlformats.org/officeDocument/2006/relationships" xmlns:a="http://schemas.openxmlformats.org/drawingml/2006/main" r:embed="Re6a0de49ebc241bd"/>
+          <a:blip xmlns:r="http://schemas.openxmlformats.org/officeDocument/2006/relationships" xmlns:a="http://schemas.openxmlformats.org/drawingml/2006/main" r:embed="Re1266ca4cdbb43e2"/>
           <a:srcRect xmlns:a="http://schemas.openxmlformats.org/drawingml/2006/main" l="24930" t="0" r="24930" b="0"/>
           <a:stretch xmlns:a="http://schemas.openxmlformats.org/drawingml/2006/main">
             <a:fillRect l="0" t="0" r="0" b="0"/>
@@ -6323,7 +6686,7 @@
           <p:cNvPr id="2" name="">
             <a:extLst xmlns:a="http://schemas.openxmlformats.org/drawingml/2006/main">
               <a:ext uri="{FF2B5EF4-FFF2-40B4-BE49-F238E27FC236}">
-                <a16:creationId xmlns:a16="http://schemas.microsoft.com/office/drawing/2014/main" id="{846BD23E-65ED-4CFA-8D67-501EE8D2E4DB}"/>
+                <a16:creationId xmlns:a16="http://schemas.microsoft.com/office/drawing/2014/main" id="{7F25663F-869E-44D7-BACB-901E1C46E4E2}"/>
               </a:ext>
             </a:extLst>
           </p:cNvPr>
@@ -6370,7 +6733,7 @@
                 <a:ea typeface="Helvetica Neue"/>
                 <a:cs typeface="Helvetica Neue"/>
               </a:rPr>
-              <a:t>影片重點二：動機需要經得起困難</a:t>
+              <a:t>影片重點一：從真實問題開始</a:t>
             </a:r>
           </a:p>
         </p:txBody>
@@ -6380,7 +6743,7 @@
           <p:cNvPr id="3" name="">
             <a:extLst xmlns:a="http://schemas.openxmlformats.org/drawingml/2006/main">
               <a:ext uri="{FF2B5EF4-FFF2-40B4-BE49-F238E27FC236}">
-                <a16:creationId xmlns:a16="http://schemas.microsoft.com/office/drawing/2014/main" id="{C4E66726-1187-414A-B480-3CA85ECFBCB2}"/>
+                <a16:creationId xmlns:a16="http://schemas.microsoft.com/office/drawing/2014/main" id="{92222322-CF55-4AB9-AE80-E9B43DB09CFB}"/>
               </a:ext>
             </a:extLst>
           </p:cNvPr>
@@ -6427,7 +6790,7 @@
                 <a:ea typeface="Helvetica Neue"/>
                 <a:cs typeface="Helvetica Neue"/>
               </a:rPr>
-              <a:t>創業會遇到不確定、拒絕與反覆修改。</a:t>
+              <a:t>創業的起點是你願意長期處理的問題。</a:t>
             </a:r>
           </a:p>
           <a:p xmlns:a="http://schemas.openxmlformats.org/drawingml/2006/main">
@@ -6450,7 +6813,7 @@
                 <a:ea typeface="Helvetica Neue"/>
                 <a:cs typeface="Helvetica Neue"/>
               </a:rPr>
-              <a:t>你的動機應該來自對問題與使用者的關心。</a:t>
+              <a:t>先觀察具體情境與受到影響的人。</a:t>
             </a:r>
           </a:p>
           <a:p xmlns:a="http://schemas.openxmlformats.org/drawingml/2006/main">
@@ -6473,7 +6836,7 @@
                 <a:ea typeface="Helvetica Neue"/>
                 <a:cs typeface="Helvetica Neue"/>
               </a:rPr>
-              <a:t>第一週不用承諾要創業，只要誠實探索。</a:t>
+              <a:t>不要只因為某個點子聽起來很新或很像成功案例。</a:t>
             </a:r>
           </a:p>
         </p:txBody>
@@ -6483,7 +6846,7 @@
           <p:cNvPr id="4" name="">
             <a:extLst xmlns:a="http://schemas.openxmlformats.org/drawingml/2006/main">
               <a:ext uri="{FF2B5EF4-FFF2-40B4-BE49-F238E27FC236}">
-                <a16:creationId xmlns:a16="http://schemas.microsoft.com/office/drawing/2014/main" id="{BAB8004B-58D4-4493-AAC4-EC4B866AC3FF}"/>
+                <a16:creationId xmlns:a16="http://schemas.microsoft.com/office/drawing/2014/main" id="{93FA9C84-B1B7-4D6B-8D42-AFA96CA881CA}"/>
               </a:ext>
             </a:extLst>
           </p:cNvPr>
@@ -6538,7 +6901,7 @@
     </p:spTree>
     <p:extLst>
       <p:ext uri="{BB962C8B-B14F-4D97-AF65-F5344CB8AC3E}">
-        <p14:creationId xmlns:p14="http://schemas.microsoft.com/office/powerpoint/2010/main" val="1076299846"/>
+        <p14:creationId xmlns:p14="http://schemas.microsoft.com/office/powerpoint/2010/main" val="446872290"/>
       </p:ext>
     </p:extLst>
   </p:cSld>

</xml_diff>